<commit_message>
Kebijakan AP: semua tugas = tugas kelompok, sendirian juga sah
- ap1_policy_update.py: sisip paragraf kebijakan di intro TUGAS 2, tulis ulang
  intro TUGAS 3 (hapus "3b wajib individu"), tulis ulang 5 komentar Tugas 1
  (berkas bersama sah; nilai = kelengkapan anotasi+narasi); nilai numerik utuh
- ap1_deck_p3.py: +1 slide statement kebijakan (26->27 slide), sub tabel
  kelompok & penugasan direvisi
- ap1_p3_setup.py: konstanta TUGAS3_INTRO diselaraskan
- PPTX baru diunggah ke Drive via Manage versions (file ID tetap)

Co-Authored-By: Claude Code <noreply@anthropic.com>
</commit_message>
<xml_diff>
--- a/ganjil-2026-2027/application-project-1/AP1_A_Pertemuan3_Ganjil2026.pptx
+++ b/ganjil-2026-2027/application-project-1/AP1_A_Pertemuan3_Ganjil2026.pptx
@@ -31,6 +31,7 @@
     <p:sldId id="279" r:id="rId31"/>
     <p:sldId id="280" r:id="rId32"/>
     <p:sldId id="281" r:id="rId33"/>
+    <p:sldId id="282" r:id="rId34"/>
   </p:sldIdLst>
   <p:sldSz cx="12191695" cy="6858000" type="screen4x3"/>
   <p:notesSz cx="6858000" cy="9144000"/>
@@ -527,7 +528,7 @@
           <a:lstStyle/>
           <a:p>
             <a:r>
-              <a:t>Poin lisan: (1) Tugas 1 yang 6 orang itu nilai plus catatannya sudah ada - tunjukkan di layar cara membuka kolom komentar. (2) Tugas 2 nol tapi tenggatnya Minggu - masih sangat bisa dikejar; Tugas 2 itu audit ergonomi wireframe masing-masing + brainstorming ide, bahan ada di modul P2. (3) 4 nama yang belum tercatat di sheet: urus sebelum kelas berakhir.</a:t>
+              <a:t>Poin lisan: (1) Tugas 1 yang 6 orang itu nilai plus catatannya sudah ada - tunjukkan di layar cara membuka kolom komentar. (2) Tugas 2 nol tapi tenggatnya Minggu - masih sangat bisa dikejar; Tugas 2 itu audit ergonomi wireframe masing-masing + brainstorming ide, bahan ada di modul P2. (3) 4 nama yang belum tercatat: konfirmasi hari ini - atau lanjut sendirian dulu, dua-duanya sah (slide kebijakan menyusul).</a:t>
             </a:r>
           </a:p>
         </p:txBody>
@@ -597,7 +598,7 @@
           <a:lstStyle/>
           <a:p>
             <a:r>
-              <a:t>Ingatkan Tugas 1: yang menyebut empty/error state mendapat nilai tertinggi. Pola yang sama dinilai lagi di Tugas 3b.</a:t>
+              <a:t>Kalau mahasiswa pakai Figma: buat text styles sekali di awal, jangan set ukuran per teks.</a:t>
             </a:r>
           </a:p>
         </p:txBody>
@@ -667,7 +668,7 @@
           <a:lstStyle/>
           <a:p>
             <a:r>
-              <a:t>Dikerjakan sekarang 30 menit di kelas. Kelompok yang sudah punya ide proyek langsung pakai konteks proyeknya - palet untuk aplikasi kesehatan beda dengan palet marketplace.</a:t>
+              <a:t>Ingatkan Tugas 1: yang menyebut empty/error state mendapat nilai tertinggi. Pola yang sama dinilai lagi di Tugas 3b.</a:t>
             </a:r>
           </a:p>
         </p:txBody>
@@ -737,7 +738,7 @@
           <a:lstStyle/>
           <a:p>
             <a:r>
-              <a:t>Fidelity MENENGAH: warna dan tipografi nyata, tapi belum perlu foto asli/ilustrasi penuh. Placeholder berwarna solid masih boleh.</a:t>
+              <a:t>Dikerjakan sekarang 30 menit di kelas. Kelompok yang sudah punya ide proyek langsung pakai konteks proyeknya - palet untuk aplikasi kesehatan beda dengan palet marketplace.</a:t>
             </a:r>
           </a:p>
         </p:txBody>
@@ -807,7 +808,7 @@
           <a:lstStyle/>
           <a:p>
             <a:r>
-              <a:t>Komponen 4 dan 5 paling menentukan nilai: Out-of-Scope membuktikan kelompok berani memilih; risiko yang jujur lebih bernilai daripada keyakinan kosong.</a:t>
+              <a:t>Fidelity MENENGAH: warna dan tipografi nyata, tapi belum perlu foto asli/ilustrasi penuh. Placeholder berwarna solid masih boleh.</a:t>
             </a:r>
           </a:p>
         </p:txBody>
@@ -877,7 +878,7 @@
           <a:lstStyle/>
           <a:p>
             <a:r>
-              <a:t>Hubungkan ke Olsen P2: hipotesis nilai + uji paling murah dulu. Proposal = kontrak mini kelompok dengan dosen.</a:t>
+              <a:t>Komponen 4 dan 5 paling menentukan nilai: Out-of-Scope membuktikan kelompok berani memilih; risiko yang jujur lebih bernilai daripada keyakinan kosong.</a:t>
             </a:r>
           </a:p>
         </p:txBody>
@@ -947,7 +948,7 @@
           <a:lstStyle/>
           <a:p>
             <a:r>
-              <a:t>Rubrik ini juga rubrik AUDIT diri: sebelum submit, cek sendiri per baris. Nilai di bawah 70 = tugas diulang per bagian yang lemah.</a:t>
+              <a:t>Hubungkan ke Olsen P2: hipotesis nilai + uji paling murah dulu. Proposal = kontrak mini kelompok dengan dosen.</a:t>
             </a:r>
           </a:p>
         </p:txBody>
@@ -1017,7 +1018,7 @@
           <a:lstStyle/>
           <a:p>
             <a:r>
-              <a:t>Pelajaran Tugas 1 dibaca keras: sebagian tugas ini individu. Berkas bersama atas nama 3 orang TIDAK menghitung untuk yang tidak mengumpulkan. Ferdi dan Notopianus: berkas versi sendiri untuk Tugas 1 masih bisa menyelamatkan nilai - batas revisi ikut tenggat.</a:t>
+              <a:t>Rubrik ini juga rubrik AUDIT diri: sebelum submit, cek sendiri per baris. Nilai di bawah 70 = tugas diulang per bagian yang lemah.</a:t>
             </a:r>
           </a:p>
         </p:txBody>
@@ -1087,7 +1088,7 @@
           <a:lstStyle/>
           <a:p>
             <a:r>
-              <a:t>Buka forumnya di layar sekarang supaya semua tahu di mana menjawab. Sasar minimal satu jawaban per orang hari ini - P2 nol posting.</a:t>
+              <a:t>Kebijakan resmi: tugas AP menuju pameran proyek, jadi semua tugas kelompok - tidak ada hukuman untuk berkas bersama. Ferdi dan Notopianus (dan siapa pun yang belum submit Tugas 1): cukup kirim berkas kelompok yang sama plus catatan anggota.</a:t>
             </a:r>
           </a:p>
         </p:txBody>
@@ -1157,6 +1158,76 @@
           <a:lstStyle/>
           <a:p>
             <a:r>
+              <a:t>Buka forumnya di layar sekarang supaya semua tahu di mana menjawab. Sasar minimal satu jawaban per orang hari ini - P2 nol posting.</a:t>
+            </a:r>
+          </a:p>
+        </p:txBody>
+      </p:sp>
+      <p:sp>
+        <p:nvSpPr>
+          <p:cNvPr id="4" name="Slide Number Placeholder 3"/>
+          <p:cNvSpPr>
+            <a:spLocks noGrp="1"/>
+          </p:cNvSpPr>
+          <p:nvPr>
+            <p:ph type="sldNum" idx="5" sz="quarter"/>
+          </p:nvPr>
+        </p:nvSpPr>
+        <p:spPr/>
+      </p:sp>
+    </p:spTree>
+  </p:cSld>
+  <p:clrMapOvr>
+    <a:masterClrMapping/>
+  </p:clrMapOvr>
+</p:notes>
+</file>
+
+<file path=ppt/notesSlides/notesSlide19.xml><?xml version="1.0" encoding="utf-8"?>
+<p:notes xmlns:a="http://schemas.openxmlformats.org/drawingml/2006/main" xmlns:p="http://schemas.openxmlformats.org/presentationml/2006/main" xmlns:r="http://schemas.openxmlformats.org/officeDocument/2006/relationships">
+  <p:cSld>
+    <p:spTree>
+      <p:nvGrpSpPr>
+        <p:cNvPr id="1" name=""/>
+        <p:cNvGrpSpPr/>
+        <p:nvPr/>
+      </p:nvGrpSpPr>
+      <p:grpSpPr>
+        <a:xfrm>
+          <a:off x="0" y="0"/>
+          <a:ext cx="0" cy="0"/>
+          <a:chOff x="0" y="0"/>
+          <a:chExt cx="0" cy="0"/>
+        </a:xfrm>
+      </p:grpSpPr>
+      <p:sp>
+        <p:nvSpPr>
+          <p:cNvPr id="2" name="Slide Image Placeholder 1"/>
+          <p:cNvSpPr>
+            <a:spLocks noGrp="1"/>
+          </p:cNvSpPr>
+          <p:nvPr>
+            <p:ph type="sldImg" idx="2"/>
+          </p:nvPr>
+        </p:nvSpPr>
+        <p:spPr/>
+      </p:sp>
+      <p:sp>
+        <p:nvSpPr>
+          <p:cNvPr id="3" name="Notes Placeholder 2"/>
+          <p:cNvSpPr>
+            <a:spLocks noGrp="1"/>
+          </p:cNvSpPr>
+          <p:nvPr>
+            <p:ph type="body" idx="3" sz="quarter"/>
+          </p:nvPr>
+        </p:nvSpPr>
+        <p:spPr/>
+        <p:txBody>
+          <a:bodyPr/>
+          <a:lstStyle/>
+          <a:p>
+            <a:r>
               <a:t>Tutup dengan komitmen waktu: 25' presentasi tiap kelompok 3-4 menit di P4. Kelompok tanpa proposal tetap presentasi dengan apa yang ada - itu bukan hukuman, itu uji paling murah.</a:t>
             </a:r>
           </a:p>
@@ -1297,7 +1368,7 @@
           <a:lstStyle/>
           <a:p>
             <a:r>
-              <a:t>Sebut: (1) Tugas 1 punya catatan revisi konkret per orang - buka komentar tugas di layar, tunjukkan caranya. (2) Daffa 90 karena state empty/error dipikirkan; Andrean 70 karena yang dikumpulkan foto kelompok tanpa bagian individu - jangan disebut nama untuk contoh negatif tanpa perlu, cukup katakan 'tugas individu, berkas bersama dinilai rendah'. (3) Kolom Exit P2 kosong semua - hari ini wajib beda.</a:t>
+              <a:t>Sebut: (1) Tugas 1 punya catatan revisi konkret per orang - buka komentar tugas di layar, tunjukkan caranya. (2) Daffa 90 karena state empty/error dipikirkan; selisih nilai antar mahasiswa = kelengkapan anotasi dan narasi, BUKAN soal individu vs kelompok - semua tugas AP itu tugas kelompok (baca slide kebijakan). (3) Kolom Exit P2 kosong semua - hari ini wajib beda.</a:t>
             </a:r>
           </a:p>
         </p:txBody>
@@ -1367,7 +1438,7 @@
           <a:lstStyle/>
           <a:p>
             <a:r>
-              <a:t>Sekali sekaligus: kelompok = unit Tugas 3c (proposal) dan proyek semester. Yang belum masuk sheet datang ke depan setelah kelas. Firmanda/Yudha lintas angkatan boleh gabung kelompok 2025 yang ada atau bentuk pasangan sendiri.</a:t>
+              <a:t>Kelompok = unit proyek semester yang dipamerkan di akhir. Yang belum masuk sheet datang ke depan setelah kelas untuk dikunci. Firmanda/Yudha/Felix/Setya: gabung kelompok yang ada, bentuk sendiri, atau kerjakan sendirian dulu - semua sah.</a:t>
             </a:r>
           </a:p>
         </p:txBody>
@@ -1437,7 +1508,7 @@
           <a:lstStyle/>
           <a:p>
             <a:r>
-              <a:t>Sisakan 5 menit terakhir untuk exit-ticket - jangan sampai terlewat lagi seperti P2. Tulis 3 pertanyaannya di papan atau tampilkan slide terakhir.</a:t>
+              <a:t>Bacakan jelas supaya tidak ada salah paham soal Tugas 1: yang kemarin mengumpulkan berkas bersama tidak bersalah; yang mengumpulkan sendiri juga sah. Yang dinilai = kelengkapan anotasi dan narasi. Ferdi &amp; Notopianus: cukup submit berkas kelompok yang sama.</a:t>
             </a:r>
           </a:p>
         </p:txBody>
@@ -1507,7 +1578,7 @@
           <a:lstStyle/>
           <a:p>
             <a:r>
-              <a:t>Jembatan dari P1-P2 ke P3. Estetika di sini = kredibilitas produk di mata pengguna pertama kali.</a:t>
+              <a:t>Sisakan 5 menit terakhir untuk exit-ticket - jangan sampai terlewat lagi seperti P2. Tulis 3 pertanyaannya di papan atau tampilkan slide terakhir.</a:t>
             </a:r>
           </a:p>
         </p:txBody>
@@ -1577,7 +1648,7 @@
           <a:lstStyle/>
           <a:p>
             <a:r>
-              <a:t>Minta 1-2 mahasiswa buka wireframe Tugas 1 mereka dan hitung gap. Biasanya muncul 11, 15, 25 - itu temuan audit pertama.</a:t>
+              <a:t>Jembatan dari P1-P2 ke P3. Estetika di sini = kredibilitas produk di mata pengguna pertama kali.</a:t>
             </a:r>
           </a:p>
         </p:txBody>
@@ -1647,7 +1718,7 @@
           <a:lstStyle/>
           <a:p>
             <a:r>
-              <a:t>Tegaskan: 5 peran ini yang diminta di Tugas 3a. Skala abu-abu bukan hiasan - teks sekunder pakai Gray-600, disabled pakai Gray-400, dst.</a:t>
+              <a:t>Minta 1-2 mahasiswa buka wireframe Tugas 1 mereka dan hitung gap. Biasanya muncul 11, 15, 25 - itu temuan audit pertama.</a:t>
             </a:r>
           </a:p>
         </p:txBody>
@@ -1717,7 +1788,7 @@
           <a:lstStyle/>
           <a:p>
             <a:r>
-              <a:t>Kalau mahasiswa pakai Figma: buat text styles sekali di awal, jangan set ukuran per teks.</a:t>
+              <a:t>Tegaskan: 5 peran ini yang diminta di Tugas 3a. Skala abu-abu bukan hiasan - teks sekunder pakai Gray-600, disabled pakai Gray-400, dst.</a:t>
             </a:r>
           </a:p>
         </p:txBody>
@@ -5091,7 +5162,7 @@
               </a:defRPr>
             </a:pPr>
             <a:r>
-              <a:t>Alat 1 - Komposisi &amp; layout: grid 8-point</a:t>
+              <a:t>Peta kerja hari ini</a:t>
             </a:r>
           </a:p>
         </p:txBody>
@@ -5126,7 +5197,7 @@
               </a:defRPr>
             </a:pPr>
             <a:r>
-              <a:t>Cek cepat wireframe Anda: tandai semua nilai gap - berapa persen yang bukan kelipatan 4/8?</a:t>
+              <a:t>Urutannya tidak boleh dibalik: mockup tanpa style guide = setiap layar punya selera sendiri.</a:t>
             </a:r>
           </a:p>
         </p:txBody>
@@ -5164,7 +5235,7 @@
                   <a:srgbClr val="1A1F2B"/>
                 </a:solidFill>
               </a:rPr>
-              <a:t>•  Semua jarak adalah </a:t>
+              <a:t>•  </a:t>
             </a:r>
             <a:r>
               <a:rPr sz="2200" b="1">
@@ -5172,7 +5243,7 @@
                   <a:srgbClr val="102545"/>
                 </a:solidFill>
               </a:rPr>
-              <a:t>kelipatan 4/8</a:t>
+              <a:t>Audit visual</a:t>
             </a:r>
             <a:r>
               <a:rPr sz="2200">
@@ -5180,7 +5251,7 @@
                   <a:srgbClr val="1A1F2B"/>
                 </a:solidFill>
               </a:rPr>
-              <a:t>: 4, 8, 16, 24, 32 px - tidak ada 13 px atau 21 px</a:t>
+              <a:t> wireframe P2 dengan kacamata estetika - catat minimal 3 temuan</a:t>
             </a:r>
           </a:p>
           <a:p>
@@ -5203,7 +5274,7 @@
                   <a:srgbClr val="102545"/>
                 </a:solidFill>
               </a:rPr>
-              <a:t>Visual grouping (proximity)</a:t>
+              <a:t>Style guide 1 halaman</a:t>
             </a:r>
             <a:r>
               <a:rPr sz="2200">
@@ -5211,7 +5282,7 @@
                   <a:srgbClr val="1A1F2B"/>
                 </a:solidFill>
               </a:rPr>
-              <a:t> - yang berhubungan didekatkan, yang tidak dipisah</a:t>
+              <a:t> - palet, type scale, komponen + state, aturan spacing</a:t>
             </a:r>
           </a:p>
           <a:p>
@@ -5234,7 +5305,7 @@
                   <a:srgbClr val="102545"/>
                 </a:solidFill>
               </a:rPr>
-              <a:t>Alignment konsisten</a:t>
+              <a:t>Mockup fidelity menengah, 2 layar</a:t>
             </a:r>
             <a:r>
               <a:rPr sz="2200">
@@ -5242,7 +5313,38 @@
                   <a:srgbClr val="1A1F2B"/>
                 </a:solidFill>
               </a:rPr>
-              <a:t> - tepi kiri elemen sejenis segaris; hierarki ditegaskan lewat jarak, bukan kekacauan</a:t>
+              <a:t> - Beranda + Layar Fitur Inti</a:t>
+            </a:r>
+          </a:p>
+          <a:p>
+            <a:pPr>
+              <a:spcBef>
+                <a:spcPts val="1100"/>
+              </a:spcBef>
+            </a:pPr>
+            <a:r>
+              <a:rPr sz="2200">
+                <a:solidFill>
+                  <a:srgbClr val="1A1F2B"/>
+                </a:solidFill>
+              </a:rPr>
+              <a:t>•  </a:t>
+            </a:r>
+            <a:r>
+              <a:rPr sz="2200" b="1">
+                <a:solidFill>
+                  <a:srgbClr val="102545"/>
+                </a:solidFill>
+              </a:rPr>
+              <a:t>Draft proposal 1-2 halaman</a:t>
+            </a:r>
+            <a:r>
+              <a:rPr sz="2200">
+                <a:solidFill>
+                  <a:srgbClr val="1A1F2B"/>
+                </a:solidFill>
+              </a:rPr>
+              <a:t> - 7 komponen, kerja kelompok</a:t>
             </a:r>
           </a:p>
         </p:txBody>
@@ -5256,6 +5358,298 @@
 </file>
 
 <file path=ppt/slides/slide11.xml><?xml version="1.0" encoding="utf-8"?>
+<p:sld xmlns:a="http://schemas.openxmlformats.org/drawingml/2006/main" xmlns:p="http://schemas.openxmlformats.org/presentationml/2006/main" xmlns:r="http://schemas.openxmlformats.org/officeDocument/2006/relationships">
+  <p:cSld>
+    <p:spTree>
+      <p:nvGrpSpPr>
+        <p:cNvPr id="1" name=""/>
+        <p:cNvGrpSpPr/>
+        <p:nvPr/>
+      </p:nvGrpSpPr>
+      <p:grpSpPr/>
+      <p:sp>
+        <p:nvSpPr>
+          <p:cNvPr id="2" name="Rectangle 1"/>
+          <p:cNvSpPr/>
+          <p:nvPr/>
+        </p:nvSpPr>
+        <p:spPr>
+          <a:xfrm>
+            <a:off x="0" y="0"/>
+            <a:ext cx="12191695" cy="6858000"/>
+          </a:xfrm>
+          <a:prstGeom prst="rect">
+            <a:avLst/>
+          </a:prstGeom>
+          <a:solidFill>
+            <a:srgbClr val="FFFFFF"/>
+          </a:solidFill>
+          <a:ln>
+            <a:noFill/>
+          </a:ln>
+          <a:effectLst/>
+        </p:spPr>
+        <p:style>
+          <a:lnRef idx="1">
+            <a:schemeClr val="accent1"/>
+          </a:lnRef>
+          <a:fillRef idx="3">
+            <a:schemeClr val="accent1"/>
+          </a:fillRef>
+          <a:effectRef idx="2">
+            <a:schemeClr val="accent1"/>
+          </a:effectRef>
+          <a:fontRef idx="minor">
+            <a:schemeClr val="lt1"/>
+          </a:fontRef>
+        </p:style>
+        <p:txBody>
+          <a:bodyPr rtlCol="0" anchor="ctr"/>
+          <a:lstStyle/>
+          <a:p>
+            <a:pPr algn="ctr"/>
+          </a:p>
+        </p:txBody>
+      </p:sp>
+      <p:sp>
+        <p:nvSpPr>
+          <p:cNvPr id="3" name="Rectangle 2"/>
+          <p:cNvSpPr/>
+          <p:nvPr/>
+        </p:nvSpPr>
+        <p:spPr>
+          <a:xfrm>
+            <a:off x="0" y="0"/>
+            <a:ext cx="12191695" cy="128016"/>
+          </a:xfrm>
+          <a:prstGeom prst="rect">
+            <a:avLst/>
+          </a:prstGeom>
+          <a:solidFill>
+            <a:srgbClr val="102545"/>
+          </a:solidFill>
+          <a:ln>
+            <a:noFill/>
+          </a:ln>
+          <a:effectLst/>
+        </p:spPr>
+        <p:style>
+          <a:lnRef idx="1">
+            <a:schemeClr val="accent1"/>
+          </a:lnRef>
+          <a:fillRef idx="3">
+            <a:schemeClr val="accent1"/>
+          </a:fillRef>
+          <a:effectRef idx="2">
+            <a:schemeClr val="accent1"/>
+          </a:effectRef>
+          <a:fontRef idx="minor">
+            <a:schemeClr val="lt1"/>
+          </a:fontRef>
+        </p:style>
+        <p:txBody>
+          <a:bodyPr rtlCol="0" anchor="ctr"/>
+          <a:lstStyle/>
+          <a:p>
+            <a:pPr algn="ctr"/>
+          </a:p>
+        </p:txBody>
+      </p:sp>
+      <p:sp>
+        <p:nvSpPr>
+          <p:cNvPr id="4" name="TextBox 3"/>
+          <p:cNvSpPr txBox="1"/>
+          <p:nvPr/>
+        </p:nvSpPr>
+        <p:spPr>
+          <a:xfrm>
+            <a:off x="777240" y="411480"/>
+            <a:ext cx="10789920" cy="914400"/>
+          </a:xfrm>
+          <a:prstGeom prst="rect">
+            <a:avLst/>
+          </a:prstGeom>
+          <a:noFill/>
+        </p:spPr>
+        <p:txBody>
+          <a:bodyPr wrap="square">
+            <a:spAutoFit/>
+          </a:bodyPr>
+          <a:lstStyle/>
+          <a:p>
+            <a:pPr>
+              <a:defRPr sz="3400" b="1">
+                <a:solidFill>
+                  <a:srgbClr val="102545"/>
+                </a:solidFill>
+              </a:defRPr>
+            </a:pPr>
+            <a:r>
+              <a:t>Alat 1 - Komposisi &amp; layout: grid 8-point</a:t>
+            </a:r>
+          </a:p>
+        </p:txBody>
+      </p:sp>
+      <p:sp>
+        <p:nvSpPr>
+          <p:cNvPr id="5" name="TextBox 4"/>
+          <p:cNvSpPr txBox="1"/>
+          <p:nvPr/>
+        </p:nvSpPr>
+        <p:spPr>
+          <a:xfrm>
+            <a:off x="777240" y="1234440"/>
+            <a:ext cx="10789920" cy="548640"/>
+          </a:xfrm>
+          <a:prstGeom prst="rect">
+            <a:avLst/>
+          </a:prstGeom>
+          <a:noFill/>
+        </p:spPr>
+        <p:txBody>
+          <a:bodyPr wrap="square">
+            <a:spAutoFit/>
+          </a:bodyPr>
+          <a:lstStyle/>
+          <a:p>
+            <a:pPr>
+              <a:defRPr sz="1900" i="1">
+                <a:solidFill>
+                  <a:srgbClr val="5A6372"/>
+                </a:solidFill>
+              </a:defRPr>
+            </a:pPr>
+            <a:r>
+              <a:t>Cek cepat wireframe Anda: tandai semua nilai gap - berapa persen yang bukan kelipatan 4/8?</a:t>
+            </a:r>
+          </a:p>
+        </p:txBody>
+      </p:sp>
+      <p:sp>
+        <p:nvSpPr>
+          <p:cNvPr id="6" name="TextBox 5"/>
+          <p:cNvSpPr txBox="1"/>
+          <p:nvPr/>
+        </p:nvSpPr>
+        <p:spPr>
+          <a:xfrm>
+            <a:off x="777240" y="1874519"/>
+            <a:ext cx="10789920" cy="4480560"/>
+          </a:xfrm>
+          <a:prstGeom prst="rect">
+            <a:avLst/>
+          </a:prstGeom>
+          <a:noFill/>
+        </p:spPr>
+        <p:txBody>
+          <a:bodyPr wrap="square">
+            <a:spAutoFit/>
+          </a:bodyPr>
+          <a:lstStyle/>
+          <a:p>
+            <a:pPr>
+              <a:spcBef>
+                <a:spcPts val="1100"/>
+              </a:spcBef>
+            </a:pPr>
+            <a:r>
+              <a:rPr sz="2200">
+                <a:solidFill>
+                  <a:srgbClr val="1A1F2B"/>
+                </a:solidFill>
+              </a:rPr>
+              <a:t>•  Semua jarak adalah </a:t>
+            </a:r>
+            <a:r>
+              <a:rPr sz="2200" b="1">
+                <a:solidFill>
+                  <a:srgbClr val="102545"/>
+                </a:solidFill>
+              </a:rPr>
+              <a:t>kelipatan 4/8</a:t>
+            </a:r>
+            <a:r>
+              <a:rPr sz="2200">
+                <a:solidFill>
+                  <a:srgbClr val="1A1F2B"/>
+                </a:solidFill>
+              </a:rPr>
+              <a:t>: 4, 8, 16, 24, 32 px - tidak ada 13 px atau 21 px</a:t>
+            </a:r>
+          </a:p>
+          <a:p>
+            <a:pPr>
+              <a:spcBef>
+                <a:spcPts val="1100"/>
+              </a:spcBef>
+            </a:pPr>
+            <a:r>
+              <a:rPr sz="2200">
+                <a:solidFill>
+                  <a:srgbClr val="1A1F2B"/>
+                </a:solidFill>
+              </a:rPr>
+              <a:t>•  </a:t>
+            </a:r>
+            <a:r>
+              <a:rPr sz="2200" b="1">
+                <a:solidFill>
+                  <a:srgbClr val="102545"/>
+                </a:solidFill>
+              </a:rPr>
+              <a:t>Visual grouping (proximity)</a:t>
+            </a:r>
+            <a:r>
+              <a:rPr sz="2200">
+                <a:solidFill>
+                  <a:srgbClr val="1A1F2B"/>
+                </a:solidFill>
+              </a:rPr>
+              <a:t> - yang berhubungan didekatkan, yang tidak dipisah</a:t>
+            </a:r>
+          </a:p>
+          <a:p>
+            <a:pPr>
+              <a:spcBef>
+                <a:spcPts val="1100"/>
+              </a:spcBef>
+            </a:pPr>
+            <a:r>
+              <a:rPr sz="2200">
+                <a:solidFill>
+                  <a:srgbClr val="1A1F2B"/>
+                </a:solidFill>
+              </a:rPr>
+              <a:t>•  </a:t>
+            </a:r>
+            <a:r>
+              <a:rPr sz="2200" b="1">
+                <a:solidFill>
+                  <a:srgbClr val="102545"/>
+                </a:solidFill>
+              </a:rPr>
+              <a:t>Alignment konsisten</a:t>
+            </a:r>
+            <a:r>
+              <a:rPr sz="2200">
+                <a:solidFill>
+                  <a:srgbClr val="1A1F2B"/>
+                </a:solidFill>
+              </a:rPr>
+              <a:t> - tepi kiri elemen sejenis segaris; hierarki ditegaskan lewat jarak, bukan kekacauan</a:t>
+            </a:r>
+          </a:p>
+        </p:txBody>
+      </p:sp>
+    </p:spTree>
+  </p:cSld>
+  <p:clrMapOvr>
+    <a:masterClrMapping/>
+  </p:clrMapOvr>
+</p:sld>
+</file>
+
+<file path=ppt/slides/slide12.xml><?xml version="1.0" encoding="utf-8"?>
 <p:sld xmlns:a="http://schemas.openxmlformats.org/drawingml/2006/main" xmlns:p="http://schemas.openxmlformats.org/presentationml/2006/main" xmlns:r="http://schemas.openxmlformats.org/officeDocument/2006/relationships">
   <p:cSld>
     <p:spTree>
@@ -5884,7 +6278,7 @@
 </p:sld>
 </file>
 
-<file path=ppt/slides/slide12.xml><?xml version="1.0" encoding="utf-8"?>
+<file path=ppt/slides/slide13.xml><?xml version="1.0" encoding="utf-8"?>
 <p:sld xmlns:a="http://schemas.openxmlformats.org/drawingml/2006/main" xmlns:p="http://schemas.openxmlformats.org/presentationml/2006/main" xmlns:r="http://schemas.openxmlformats.org/officeDocument/2006/relationships">
   <p:cSld>
     <p:spTree>
@@ -6191,7 +6585,7 @@
 </p:sld>
 </file>
 
-<file path=ppt/slides/slide13.xml><?xml version="1.0" encoding="utf-8"?>
+<file path=ppt/slides/slide14.xml><?xml version="1.0" encoding="utf-8"?>
 <p:sld xmlns:a="http://schemas.openxmlformats.org/drawingml/2006/main" xmlns:p="http://schemas.openxmlformats.org/presentationml/2006/main" xmlns:r="http://schemas.openxmlformats.org/officeDocument/2006/relationships">
   <p:cSld>
     <p:spTree>
@@ -6498,7 +6892,7 @@
 </p:sld>
 </file>
 
-<file path=ppt/slides/slide14.xml><?xml version="1.0" encoding="utf-8"?>
+<file path=ppt/slides/slide15.xml><?xml version="1.0" encoding="utf-8"?>
 <p:sld xmlns:a="http://schemas.openxmlformats.org/drawingml/2006/main" xmlns:p="http://schemas.openxmlformats.org/presentationml/2006/main" xmlns:r="http://schemas.openxmlformats.org/officeDocument/2006/relationships">
   <p:cSld>
     <p:spTree>
@@ -6713,7 +7107,7 @@
 </p:sld>
 </file>
 
-<file path=ppt/slides/slide15.xml><?xml version="1.0" encoding="utf-8"?>
+<file path=ppt/slides/slide16.xml><?xml version="1.0" encoding="utf-8"?>
 <p:sld xmlns:a="http://schemas.openxmlformats.org/drawingml/2006/main" xmlns:p="http://schemas.openxmlformats.org/presentationml/2006/main" xmlns:r="http://schemas.openxmlformats.org/officeDocument/2006/relationships">
   <p:cSld>
     <p:spTree>
@@ -6876,7 +7270,7 @@
               </a:defRPr>
             </a:pPr>
             <a:r>
-              <a:t>Output Tugas 3a: StyleGuide_P3.pdf (individu atau kelompok kecil).</a:t>
+              <a:t>Output Tugas 3a: StyleGuide_P3.pdf (kelompok; sendirian juga sah).</a:t>
             </a:r>
           </a:p>
         </p:txBody>
@@ -7036,7 +7430,7 @@
 </p:sld>
 </file>
 
-<file path=ppt/slides/slide16.xml><?xml version="1.0" encoding="utf-8"?>
+<file path=ppt/slides/slide17.xml><?xml version="1.0" encoding="utf-8"?>
 <p:sld xmlns:a="http://schemas.openxmlformats.org/drawingml/2006/main" xmlns:p="http://schemas.openxmlformats.org/presentationml/2006/main" xmlns:r="http://schemas.openxmlformats.org/officeDocument/2006/relationships">
   <p:cSld>
     <p:spTree>
@@ -7251,7 +7645,7 @@
 </p:sld>
 </file>
 
-<file path=ppt/slides/slide17.xml><?xml version="1.0" encoding="utf-8"?>
+<file path=ppt/slides/slide18.xml><?xml version="1.0" encoding="utf-8"?>
 <p:sld xmlns:a="http://schemas.openxmlformats.org/drawingml/2006/main" xmlns:p="http://schemas.openxmlformats.org/presentationml/2006/main" xmlns:r="http://schemas.openxmlformats.org/officeDocument/2006/relationships">
   <p:cSld>
     <p:spTree>
@@ -7414,7 +7808,7 @@
               </a:defRPr>
             </a:pPr>
             <a:r>
-              <a:t>Output Tugas 3b (individu): Mockup_P3_Home.pdf + Mockup_P3_FiturInti.pdf.</a:t>
+              <a:t>Output Tugas 3b (kelompok; sendirian juga sah): Mockup_P3_Home.pdf + Mockup_P3_FiturInti.pdf.</a:t>
             </a:r>
           </a:p>
         </p:txBody>
@@ -7574,7 +7968,7 @@
 </p:sld>
 </file>
 
-<file path=ppt/slides/slide18.xml><?xml version="1.0" encoding="utf-8"?>
+<file path=ppt/slides/slide19.xml><?xml version="1.0" encoding="utf-8"?>
 <p:sld xmlns:a="http://schemas.openxmlformats.org/drawingml/2006/main" xmlns:p="http://schemas.openxmlformats.org/presentationml/2006/main" xmlns:r="http://schemas.openxmlformats.org/officeDocument/2006/relationships">
   <p:cSld>
     <p:spTree>
@@ -7789,7 +8183,497 @@
 </p:sld>
 </file>
 
-<file path=ppt/slides/slide19.xml><?xml version="1.0" encoding="utf-8"?>
+<file path=ppt/slides/slide2.xml><?xml version="1.0" encoding="utf-8"?>
+<p:sld xmlns:a="http://schemas.openxmlformats.org/drawingml/2006/main" xmlns:p="http://schemas.openxmlformats.org/presentationml/2006/main" xmlns:r="http://schemas.openxmlformats.org/officeDocument/2006/relationships">
+  <p:cSld>
+    <p:spTree>
+      <p:nvGrpSpPr>
+        <p:cNvPr id="1" name=""/>
+        <p:cNvGrpSpPr/>
+        <p:nvPr/>
+      </p:nvGrpSpPr>
+      <p:grpSpPr/>
+      <p:sp>
+        <p:nvSpPr>
+          <p:cNvPr id="2" name="Rectangle 1"/>
+          <p:cNvSpPr/>
+          <p:nvPr/>
+        </p:nvSpPr>
+        <p:spPr>
+          <a:xfrm>
+            <a:off x="0" y="0"/>
+            <a:ext cx="12191695" cy="6858000"/>
+          </a:xfrm>
+          <a:prstGeom prst="rect">
+            <a:avLst/>
+          </a:prstGeom>
+          <a:solidFill>
+            <a:srgbClr val="FFFFFF"/>
+          </a:solidFill>
+          <a:ln>
+            <a:noFill/>
+          </a:ln>
+          <a:effectLst/>
+        </p:spPr>
+        <p:style>
+          <a:lnRef idx="1">
+            <a:schemeClr val="accent1"/>
+          </a:lnRef>
+          <a:fillRef idx="3">
+            <a:schemeClr val="accent1"/>
+          </a:fillRef>
+          <a:effectRef idx="2">
+            <a:schemeClr val="accent1"/>
+          </a:effectRef>
+          <a:fontRef idx="minor">
+            <a:schemeClr val="lt1"/>
+          </a:fontRef>
+        </p:style>
+        <p:txBody>
+          <a:bodyPr rtlCol="0" anchor="ctr"/>
+          <a:lstStyle/>
+          <a:p>
+            <a:pPr algn="ctr"/>
+          </a:p>
+        </p:txBody>
+      </p:sp>
+      <p:sp>
+        <p:nvSpPr>
+          <p:cNvPr id="3" name="Rectangle 2"/>
+          <p:cNvSpPr/>
+          <p:nvPr/>
+        </p:nvSpPr>
+        <p:spPr>
+          <a:xfrm>
+            <a:off x="0" y="0"/>
+            <a:ext cx="12191695" cy="128016"/>
+          </a:xfrm>
+          <a:prstGeom prst="rect">
+            <a:avLst/>
+          </a:prstGeom>
+          <a:solidFill>
+            <a:srgbClr val="102545"/>
+          </a:solidFill>
+          <a:ln>
+            <a:noFill/>
+          </a:ln>
+          <a:effectLst/>
+        </p:spPr>
+        <p:style>
+          <a:lnRef idx="1">
+            <a:schemeClr val="accent1"/>
+          </a:lnRef>
+          <a:fillRef idx="3">
+            <a:schemeClr val="accent1"/>
+          </a:fillRef>
+          <a:effectRef idx="2">
+            <a:schemeClr val="accent1"/>
+          </a:effectRef>
+          <a:fontRef idx="minor">
+            <a:schemeClr val="lt1"/>
+          </a:fontRef>
+        </p:style>
+        <p:txBody>
+          <a:bodyPr rtlCol="0" anchor="ctr"/>
+          <a:lstStyle/>
+          <a:p>
+            <a:pPr algn="ctr"/>
+          </a:p>
+        </p:txBody>
+      </p:sp>
+      <p:sp>
+        <p:nvSpPr>
+          <p:cNvPr id="4" name="TextBox 3"/>
+          <p:cNvSpPr txBox="1"/>
+          <p:nvPr/>
+        </p:nvSpPr>
+        <p:spPr>
+          <a:xfrm>
+            <a:off x="777240" y="411480"/>
+            <a:ext cx="10789920" cy="914400"/>
+          </a:xfrm>
+          <a:prstGeom prst="rect">
+            <a:avLst/>
+          </a:prstGeom>
+          <a:noFill/>
+        </p:spPr>
+        <p:txBody>
+          <a:bodyPr wrap="square">
+            <a:spAutoFit/>
+          </a:bodyPr>
+          <a:lstStyle/>
+          <a:p>
+            <a:pPr>
+              <a:defRPr sz="3400" b="1">
+                <a:solidFill>
+                  <a:srgbClr val="102545"/>
+                </a:solidFill>
+              </a:defRPr>
+            </a:pPr>
+            <a:r>
+              <a:t>Laporan feedback - Minggu 3 (17-23 Sep)</a:t>
+            </a:r>
+          </a:p>
+        </p:txBody>
+      </p:sp>
+      <p:sp>
+        <p:nvSpPr>
+          <p:cNvPr id="5" name="TextBox 4"/>
+          <p:cNvSpPr txBox="1"/>
+          <p:nvPr/>
+        </p:nvSpPr>
+        <p:spPr>
+          <a:xfrm>
+            <a:off x="777240" y="1188720"/>
+            <a:ext cx="10789920" cy="457200"/>
+          </a:xfrm>
+          <a:prstGeom prst="rect">
+            <a:avLst/>
+          </a:prstGeom>
+          <a:noFill/>
+        </p:spPr>
+        <p:txBody>
+          <a:bodyPr wrap="square">
+            <a:spAutoFit/>
+          </a:bodyPr>
+          <a:lstStyle/>
+          <a:p>
+            <a:pPr>
+              <a:defRPr sz="1800" i="1">
+                <a:solidFill>
+                  <a:srgbClr val="5A6372"/>
+                </a:solidFill>
+              </a:defRPr>
+            </a:pPr>
+            <a:r>
+              <a:t>Angka dibaca langsung dari eBelajar pagi ini, bukan perkiraan.</a:t>
+            </a:r>
+          </a:p>
+        </p:txBody>
+      </p:sp>
+      <p:graphicFrame>
+        <p:nvGraphicFramePr>
+          <p:cNvPr id="6" name="Table 5"/>
+          <p:cNvGraphicFramePr>
+            <a:graphicFrameLocks noGrp="1"/>
+          </p:cNvGraphicFramePr>
+          <p:nvPr/>
+        </p:nvGraphicFramePr>
+        <p:xfrm>
+          <a:off x="777240" y="1783080"/>
+          <a:ext cx="10652760" cy="2359152"/>
+        </p:xfrm>
+        <a:graphic>
+          <a:graphicData uri="http://schemas.openxmlformats.org/drawingml/2006/table">
+            <a:tbl>
+              <a:tblPr firstRow="1" bandRow="1">
+                <a:tableStyleId>{5C22544A-7EE6-4342-B048-85BDC9FD1C3A}</a:tableStyleId>
+              </a:tblPr>
+              <a:tblGrid>
+                <a:gridCol w="3195828"/>
+                <a:gridCol w="7456932"/>
+              </a:tblGrid>
+              <a:tr h="393192">
+                <a:tc>
+                  <a:txBody>
+                    <a:bodyPr/>
+                    <a:lstStyle/>
+                    <a:p>
+                      <a:pPr>
+                        <a:defRPr sz="1600" b="1">
+                          <a:solidFill>
+                            <a:srgbClr val="FFFFFF"/>
+                          </a:solidFill>
+                        </a:defRPr>
+                      </a:pPr>
+                      <a:r>
+                        <a:t>Yang saya periksa</a:t>
+                      </a:r>
+                    </a:p>
+                  </a:txBody>
+                  <a:tcPr anchor="ctr">
+                    <a:solidFill>
+                      <a:srgbClr val="102545"/>
+                    </a:solidFill>
+                  </a:tcPr>
+                </a:tc>
+                <a:tc>
+                  <a:txBody>
+                    <a:bodyPr/>
+                    <a:lstStyle/>
+                    <a:p>
+                      <a:pPr>
+                        <a:defRPr sz="1600" b="1">
+                          <a:solidFill>
+                            <a:srgbClr val="FFFFFF"/>
+                          </a:solidFill>
+                        </a:defRPr>
+                      </a:pPr>
+                      <a:r>
+                        <a:t>Hasil per 24 September pagi</a:t>
+                      </a:r>
+                    </a:p>
+                  </a:txBody>
+                  <a:tcPr anchor="ctr">
+                    <a:solidFill>
+                      <a:srgbClr val="102545"/>
+                    </a:solidFill>
+                  </a:tcPr>
+                </a:tc>
+              </a:tr>
+              <a:tr h="393192">
+                <a:tc>
+                  <a:txBody>
+                    <a:bodyPr/>
+                    <a:lstStyle/>
+                    <a:p>
+                      <a:pPr>
+                        <a:defRPr sz="1600" b="1">
+                          <a:solidFill>
+                            <a:srgbClr val="102545"/>
+                          </a:solidFill>
+                        </a:defRPr>
+                      </a:pPr>
+                      <a:r>
+                        <a:t>Tugas 1</a:t>
+                      </a:r>
+                    </a:p>
+                  </a:txBody>
+                  <a:tcPr anchor="ctr">
+                    <a:solidFill>
+                      <a:srgbClr val="F5F7FA"/>
+                    </a:solidFill>
+                  </a:tcPr>
+                </a:tc>
+                <a:tc>
+                  <a:txBody>
+                    <a:bodyPr/>
+                    <a:lstStyle/>
+                    <a:p>
+                      <a:pPr>
+                        <a:defRPr sz="1600" b="1">
+                          <a:solidFill>
+                            <a:srgbClr val="102545"/>
+                          </a:solidFill>
+                        </a:defRPr>
+                      </a:pPr>
+                      <a:r>
+                        <a:t>6 dari 24 terkumpul - keenamnya SUDAH dinilai dengan catatan revisi di kolom komentar tugas</a:t>
+                      </a:r>
+                    </a:p>
+                  </a:txBody>
+                  <a:tcPr anchor="ctr">
+                    <a:solidFill>
+                      <a:srgbClr val="F5F7FA"/>
+                    </a:solidFill>
+                  </a:tcPr>
+                </a:tc>
+              </a:tr>
+              <a:tr h="393192">
+                <a:tc>
+                  <a:txBody>
+                    <a:bodyPr/>
+                    <a:lstStyle/>
+                    <a:p>
+                      <a:pPr>
+                        <a:defRPr sz="1600" b="1">
+                          <a:solidFill>
+                            <a:srgbClr val="102545"/>
+                          </a:solidFill>
+                        </a:defRPr>
+                      </a:pPr>
+                      <a:r>
+                        <a:t>Tugas 2</a:t>
+                      </a:r>
+                    </a:p>
+                  </a:txBody>
+                  <a:tcPr anchor="ctr">
+                    <a:solidFill>
+                      <a:srgbClr val="FFFFFF"/>
+                    </a:solidFill>
+                  </a:tcPr>
+                </a:tc>
+                <a:tc>
+                  <a:txBody>
+                    <a:bodyPr/>
+                    <a:lstStyle/>
+                    <a:p>
+                      <a:pPr>
+                        <a:defRPr sz="1600" b="1">
+                          <a:solidFill>
+                            <a:srgbClr val="102545"/>
+                          </a:solidFill>
+                        </a:defRPr>
+                      </a:pPr>
+                      <a:r>
+                        <a:t>0 dari 24. Tenggat Minggu 27 Sep pukul 23.55 - sisa 3 hari</a:t>
+                      </a:r>
+                    </a:p>
+                  </a:txBody>
+                  <a:tcPr anchor="ctr">
+                    <a:solidFill>
+                      <a:srgbClr val="FFFFFF"/>
+                    </a:solidFill>
+                  </a:tcPr>
+                </a:tc>
+              </a:tr>
+              <a:tr h="393192">
+                <a:tc>
+                  <a:txBody>
+                    <a:bodyPr/>
+                    <a:lstStyle/>
+                    <a:p>
+                      <a:pPr>
+                        <a:defRPr sz="1600" b="1">
+                          <a:solidFill>
+                            <a:srgbClr val="102545"/>
+                          </a:solidFill>
+                        </a:defRPr>
+                      </a:pPr>
+                      <a:r>
+                        <a:t>Exit-ticket P2</a:t>
+                      </a:r>
+                    </a:p>
+                  </a:txBody>
+                  <a:tcPr anchor="ctr">
+                    <a:solidFill>
+                      <a:srgbClr val="F5F7FA"/>
+                    </a:solidFill>
+                  </a:tcPr>
+                </a:tc>
+                <a:tc>
+                  <a:txBody>
+                    <a:bodyPr/>
+                    <a:lstStyle/>
+                    <a:p>
+                      <a:pPr>
+                        <a:defRPr sz="1600" b="1">
+                          <a:solidFill>
+                            <a:srgbClr val="102545"/>
+                          </a:solidFill>
+                        </a:defRPr>
+                      </a:pPr>
+                      <a:r>
+                        <a:t>0 posting. Forum terbuka dan tetap dinilai</a:t>
+                      </a:r>
+                    </a:p>
+                  </a:txBody>
+                  <a:tcPr anchor="ctr">
+                    <a:solidFill>
+                      <a:srgbClr val="F5F7FA"/>
+                    </a:solidFill>
+                  </a:tcPr>
+                </a:tc>
+              </a:tr>
+              <a:tr h="393192">
+                <a:tc>
+                  <a:txBody>
+                    <a:bodyPr/>
+                    <a:lstStyle/>
+                    <a:p>
+                      <a:pPr>
+                        <a:defRPr sz="1600" b="1">
+                          <a:solidFill>
+                            <a:srgbClr val="102545"/>
+                          </a:solidFill>
+                        </a:defRPr>
+                      </a:pPr>
+                      <a:r>
+                        <a:t>Perkenalan</a:t>
+                      </a:r>
+                    </a:p>
+                  </a:txBody>
+                  <a:tcPr anchor="ctr">
+                    <a:solidFill>
+                      <a:srgbClr val="FFFFFF"/>
+                    </a:solidFill>
+                  </a:tcPr>
+                </a:tc>
+                <a:tc>
+                  <a:txBody>
+                    <a:bodyPr/>
+                    <a:lstStyle/>
+                    <a:p>
+                      <a:pPr>
+                        <a:defRPr sz="1600" b="1">
+                          <a:solidFill>
+                            <a:srgbClr val="102545"/>
+                          </a:solidFill>
+                        </a:defRPr>
+                      </a:pPr>
+                      <a:r>
+                        <a:t>5 sudah dibalas dan dinilai 80 (Tyo, Devan, Andrean, Jibril, Marchel)</a:t>
+                      </a:r>
+                    </a:p>
+                  </a:txBody>
+                  <a:tcPr anchor="ctr">
+                    <a:solidFill>
+                      <a:srgbClr val="FFFFFF"/>
+                    </a:solidFill>
+                  </a:tcPr>
+                </a:tc>
+              </a:tr>
+              <a:tr h="393192">
+                <a:tc>
+                  <a:txBody>
+                    <a:bodyPr/>
+                    <a:lstStyle/>
+                    <a:p>
+                      <a:pPr>
+                        <a:defRPr sz="1600" b="1">
+                          <a:solidFill>
+                            <a:srgbClr val="102545"/>
+                          </a:solidFill>
+                        </a:defRPr>
+                      </a:pPr>
+                      <a:r>
+                        <a:t>Kelompok</a:t>
+                      </a:r>
+                    </a:p>
+                  </a:txBody>
+                  <a:tcPr anchor="ctr">
+                    <a:solidFill>
+                      <a:srgbClr val="F5F7FA"/>
+                    </a:solidFill>
+                  </a:tcPr>
+                </a:tc>
+                <a:tc>
+                  <a:txBody>
+                    <a:bodyPr/>
+                    <a:lstStyle/>
+                    <a:p>
+                      <a:pPr>
+                        <a:defRPr sz="1600" b="1">
+                          <a:solidFill>
+                            <a:srgbClr val="102545"/>
+                          </a:solidFill>
+                        </a:defRPr>
+                      </a:pPr>
+                      <a:r>
+                        <a:t>6 kelompok terdaftar di sheet Drive. 4 nama belum tercatat: Firmanda, Yudha, Felix, Setya - kelompok mungkin sudah terbentuk, konfirmasi hari ini</a:t>
+                      </a:r>
+                    </a:p>
+                  </a:txBody>
+                  <a:tcPr anchor="ctr">
+                    <a:solidFill>
+                      <a:srgbClr val="F5F7FA"/>
+                    </a:solidFill>
+                  </a:tcPr>
+                </a:tc>
+              </a:tr>
+            </a:tbl>
+          </a:graphicData>
+        </a:graphic>
+      </p:graphicFrame>
+    </p:spTree>
+  </p:cSld>
+  <p:clrMapOvr>
+    <a:masterClrMapping/>
+  </p:clrMapOvr>
+</p:sld>
+</file>
+
+<file path=ppt/slides/slide20.xml><?xml version="1.0" encoding="utf-8"?>
 <p:sld xmlns:a="http://schemas.openxmlformats.org/drawingml/2006/main" xmlns:p="http://schemas.openxmlformats.org/presentationml/2006/main" xmlns:r="http://schemas.openxmlformats.org/officeDocument/2006/relationships">
   <p:cSld>
     <p:spTree>
@@ -8375,7 +9259,187 @@
 </p:sld>
 </file>
 
-<file path=ppt/slides/slide2.xml><?xml version="1.0" encoding="utf-8"?>
+<file path=ppt/slides/slide21.xml><?xml version="1.0" encoding="utf-8"?>
+<p:sld xmlns:a="http://schemas.openxmlformats.org/drawingml/2006/main" xmlns:p="http://schemas.openxmlformats.org/presentationml/2006/main" xmlns:r="http://schemas.openxmlformats.org/officeDocument/2006/relationships">
+  <p:cSld>
+    <p:spTree>
+      <p:nvGrpSpPr>
+        <p:cNvPr id="1" name=""/>
+        <p:cNvGrpSpPr/>
+        <p:nvPr/>
+      </p:nvGrpSpPr>
+      <p:grpSpPr/>
+      <p:sp>
+        <p:nvSpPr>
+          <p:cNvPr id="2" name="Rectangle 1"/>
+          <p:cNvSpPr/>
+          <p:nvPr/>
+        </p:nvSpPr>
+        <p:spPr>
+          <a:xfrm>
+            <a:off x="0" y="0"/>
+            <a:ext cx="12191695" cy="6858000"/>
+          </a:xfrm>
+          <a:prstGeom prst="rect">
+            <a:avLst/>
+          </a:prstGeom>
+          <a:solidFill>
+            <a:srgbClr val="F5F7FA"/>
+          </a:solidFill>
+          <a:ln>
+            <a:noFill/>
+          </a:ln>
+          <a:effectLst/>
+        </p:spPr>
+        <p:style>
+          <a:lnRef idx="1">
+            <a:schemeClr val="accent1"/>
+          </a:lnRef>
+          <a:fillRef idx="3">
+            <a:schemeClr val="accent1"/>
+          </a:fillRef>
+          <a:effectRef idx="2">
+            <a:schemeClr val="accent1"/>
+          </a:effectRef>
+          <a:fontRef idx="minor">
+            <a:schemeClr val="lt1"/>
+          </a:fontRef>
+        </p:style>
+        <p:txBody>
+          <a:bodyPr rtlCol="0" anchor="ctr"/>
+          <a:lstStyle/>
+          <a:p>
+            <a:pPr algn="ctr"/>
+          </a:p>
+        </p:txBody>
+      </p:sp>
+      <p:sp>
+        <p:nvSpPr>
+          <p:cNvPr id="3" name="Rectangle 2"/>
+          <p:cNvSpPr/>
+          <p:nvPr/>
+        </p:nvSpPr>
+        <p:spPr>
+          <a:xfrm>
+            <a:off x="777240" y="2240280"/>
+            <a:ext cx="128016" cy="2011680"/>
+          </a:xfrm>
+          <a:prstGeom prst="rect">
+            <a:avLst/>
+          </a:prstGeom>
+          <a:solidFill>
+            <a:srgbClr val="E6A023"/>
+          </a:solidFill>
+          <a:ln>
+            <a:noFill/>
+          </a:ln>
+          <a:effectLst/>
+        </p:spPr>
+        <p:style>
+          <a:lnRef idx="1">
+            <a:schemeClr val="accent1"/>
+          </a:lnRef>
+          <a:fillRef idx="3">
+            <a:schemeClr val="accent1"/>
+          </a:fillRef>
+          <a:effectRef idx="2">
+            <a:schemeClr val="accent1"/>
+          </a:effectRef>
+          <a:fontRef idx="minor">
+            <a:schemeClr val="lt1"/>
+          </a:fontRef>
+        </p:style>
+        <p:txBody>
+          <a:bodyPr rtlCol="0" anchor="ctr"/>
+          <a:lstStyle/>
+          <a:p>
+            <a:pPr algn="ctr"/>
+          </a:p>
+        </p:txBody>
+      </p:sp>
+      <p:sp>
+        <p:nvSpPr>
+          <p:cNvPr id="4" name="TextBox 3"/>
+          <p:cNvSpPr txBox="1"/>
+          <p:nvPr/>
+        </p:nvSpPr>
+        <p:spPr>
+          <a:xfrm>
+            <a:off x="1234440" y="2148840"/>
+            <a:ext cx="9966960" cy="2103120"/>
+          </a:xfrm>
+          <a:prstGeom prst="rect">
+            <a:avLst/>
+          </a:prstGeom>
+          <a:noFill/>
+        </p:spPr>
+        <p:txBody>
+          <a:bodyPr wrap="square">
+            <a:spAutoFit/>
+          </a:bodyPr>
+          <a:lstStyle/>
+          <a:p>
+            <a:pPr>
+              <a:defRPr sz="3800" b="1">
+                <a:solidFill>
+                  <a:srgbClr val="102545"/>
+                </a:solidFill>
+              </a:defRPr>
+            </a:pPr>
+            <a:r>
+              <a:t>"Kita tidak membangun X"</a:t>
+            </a:r>
+            <a:br/>
+            <a:r>
+              <a:t>adalah kalimat paling mahal di proposal.</a:t>
+            </a:r>
+          </a:p>
+        </p:txBody>
+      </p:sp>
+      <p:sp>
+        <p:nvSpPr>
+          <p:cNvPr id="5" name="TextBox 4"/>
+          <p:cNvSpPr txBox="1"/>
+          <p:nvPr/>
+        </p:nvSpPr>
+        <p:spPr>
+          <a:xfrm>
+            <a:off x="1234440" y="4434840"/>
+            <a:ext cx="9966960" cy="1371600"/>
+          </a:xfrm>
+          <a:prstGeom prst="rect">
+            <a:avLst/>
+          </a:prstGeom>
+          <a:noFill/>
+        </p:spPr>
+        <p:txBody>
+          <a:bodyPr wrap="square">
+            <a:spAutoFit/>
+          </a:bodyPr>
+          <a:lstStyle/>
+          <a:p>
+            <a:pPr>
+              <a:defRPr sz="2100">
+                <a:solidFill>
+                  <a:srgbClr val="5A6372"/>
+                </a:solidFill>
+              </a:defRPr>
+            </a:pPr>
+            <a:r>
+              <a:t>Out-of-Scope menjaga 5 minggu ke depan tidak bocor jadi segala-galanya. Metrik keberhasilan membuat minggu depan ada angka untuk dibandingkan, bukan sekadar perasaan.</a:t>
+            </a:r>
+          </a:p>
+        </p:txBody>
+      </p:sp>
+    </p:spTree>
+  </p:cSld>
+  <p:clrMapOvr>
+    <a:masterClrMapping/>
+  </p:clrMapOvr>
+</p:sld>
+</file>
+
+<file path=ppt/slides/slide22.xml><?xml version="1.0" encoding="utf-8"?>
 <p:sld xmlns:a="http://schemas.openxmlformats.org/drawingml/2006/main" xmlns:p="http://schemas.openxmlformats.org/presentationml/2006/main" xmlns:r="http://schemas.openxmlformats.org/officeDocument/2006/relationships">
   <p:cSld>
     <p:spTree>
@@ -8503,7 +9567,7 @@
               </a:defRPr>
             </a:pPr>
             <a:r>
-              <a:t>Laporan feedback - Minggu 3 (17-23 Sep)</a:t>
+              <a:t>Rubrik penilaian Tugas 3 (100 poin)</a:t>
             </a:r>
           </a:p>
         </p:txBody>
@@ -8538,677 +9602,7 @@
               </a:defRPr>
             </a:pPr>
             <a:r>
-              <a:t>Angka dibaca langsung dari eBelajar pagi ini, bukan perkiraan.</a:t>
-            </a:r>
-          </a:p>
-        </p:txBody>
-      </p:sp>
-      <p:graphicFrame>
-        <p:nvGraphicFramePr>
-          <p:cNvPr id="6" name="Table 5"/>
-          <p:cNvGraphicFramePr>
-            <a:graphicFrameLocks noGrp="1"/>
-          </p:cNvGraphicFramePr>
-          <p:nvPr/>
-        </p:nvGraphicFramePr>
-        <p:xfrm>
-          <a:off x="777240" y="1783080"/>
-          <a:ext cx="10652760" cy="2359152"/>
-        </p:xfrm>
-        <a:graphic>
-          <a:graphicData uri="http://schemas.openxmlformats.org/drawingml/2006/table">
-            <a:tbl>
-              <a:tblPr firstRow="1" bandRow="1">
-                <a:tableStyleId>{5C22544A-7EE6-4342-B048-85BDC9FD1C3A}</a:tableStyleId>
-              </a:tblPr>
-              <a:tblGrid>
-                <a:gridCol w="3195828"/>
-                <a:gridCol w="7456932"/>
-              </a:tblGrid>
-              <a:tr h="393192">
-                <a:tc>
-                  <a:txBody>
-                    <a:bodyPr/>
-                    <a:lstStyle/>
-                    <a:p>
-                      <a:pPr>
-                        <a:defRPr sz="1600" b="1">
-                          <a:solidFill>
-                            <a:srgbClr val="FFFFFF"/>
-                          </a:solidFill>
-                        </a:defRPr>
-                      </a:pPr>
-                      <a:r>
-                        <a:t>Yang saya periksa</a:t>
-                      </a:r>
-                    </a:p>
-                  </a:txBody>
-                  <a:tcPr anchor="ctr">
-                    <a:solidFill>
-                      <a:srgbClr val="102545"/>
-                    </a:solidFill>
-                  </a:tcPr>
-                </a:tc>
-                <a:tc>
-                  <a:txBody>
-                    <a:bodyPr/>
-                    <a:lstStyle/>
-                    <a:p>
-                      <a:pPr>
-                        <a:defRPr sz="1600" b="1">
-                          <a:solidFill>
-                            <a:srgbClr val="FFFFFF"/>
-                          </a:solidFill>
-                        </a:defRPr>
-                      </a:pPr>
-                      <a:r>
-                        <a:t>Hasil per 24 September pagi</a:t>
-                      </a:r>
-                    </a:p>
-                  </a:txBody>
-                  <a:tcPr anchor="ctr">
-                    <a:solidFill>
-                      <a:srgbClr val="102545"/>
-                    </a:solidFill>
-                  </a:tcPr>
-                </a:tc>
-              </a:tr>
-              <a:tr h="393192">
-                <a:tc>
-                  <a:txBody>
-                    <a:bodyPr/>
-                    <a:lstStyle/>
-                    <a:p>
-                      <a:pPr>
-                        <a:defRPr sz="1600" b="1">
-                          <a:solidFill>
-                            <a:srgbClr val="102545"/>
-                          </a:solidFill>
-                        </a:defRPr>
-                      </a:pPr>
-                      <a:r>
-                        <a:t>Tugas 1</a:t>
-                      </a:r>
-                    </a:p>
-                  </a:txBody>
-                  <a:tcPr anchor="ctr">
-                    <a:solidFill>
-                      <a:srgbClr val="F5F7FA"/>
-                    </a:solidFill>
-                  </a:tcPr>
-                </a:tc>
-                <a:tc>
-                  <a:txBody>
-                    <a:bodyPr/>
-                    <a:lstStyle/>
-                    <a:p>
-                      <a:pPr>
-                        <a:defRPr sz="1600" b="1">
-                          <a:solidFill>
-                            <a:srgbClr val="102545"/>
-                          </a:solidFill>
-                        </a:defRPr>
-                      </a:pPr>
-                      <a:r>
-                        <a:t>6 dari 24 terkumpul - keenamnya SUDAH dinilai dengan catatan revisi di kolom komentar tugas</a:t>
-                      </a:r>
-                    </a:p>
-                  </a:txBody>
-                  <a:tcPr anchor="ctr">
-                    <a:solidFill>
-                      <a:srgbClr val="F5F7FA"/>
-                    </a:solidFill>
-                  </a:tcPr>
-                </a:tc>
-              </a:tr>
-              <a:tr h="393192">
-                <a:tc>
-                  <a:txBody>
-                    <a:bodyPr/>
-                    <a:lstStyle/>
-                    <a:p>
-                      <a:pPr>
-                        <a:defRPr sz="1600" b="1">
-                          <a:solidFill>
-                            <a:srgbClr val="102545"/>
-                          </a:solidFill>
-                        </a:defRPr>
-                      </a:pPr>
-                      <a:r>
-                        <a:t>Tugas 2</a:t>
-                      </a:r>
-                    </a:p>
-                  </a:txBody>
-                  <a:tcPr anchor="ctr">
-                    <a:solidFill>
-                      <a:srgbClr val="FFFFFF"/>
-                    </a:solidFill>
-                  </a:tcPr>
-                </a:tc>
-                <a:tc>
-                  <a:txBody>
-                    <a:bodyPr/>
-                    <a:lstStyle/>
-                    <a:p>
-                      <a:pPr>
-                        <a:defRPr sz="1600" b="1">
-                          <a:solidFill>
-                            <a:srgbClr val="102545"/>
-                          </a:solidFill>
-                        </a:defRPr>
-                      </a:pPr>
-                      <a:r>
-                        <a:t>0 dari 24. Tenggat Minggu 27 Sep pukul 23.55 - sisa 3 hari</a:t>
-                      </a:r>
-                    </a:p>
-                  </a:txBody>
-                  <a:tcPr anchor="ctr">
-                    <a:solidFill>
-                      <a:srgbClr val="FFFFFF"/>
-                    </a:solidFill>
-                  </a:tcPr>
-                </a:tc>
-              </a:tr>
-              <a:tr h="393192">
-                <a:tc>
-                  <a:txBody>
-                    <a:bodyPr/>
-                    <a:lstStyle/>
-                    <a:p>
-                      <a:pPr>
-                        <a:defRPr sz="1600" b="1">
-                          <a:solidFill>
-                            <a:srgbClr val="102545"/>
-                          </a:solidFill>
-                        </a:defRPr>
-                      </a:pPr>
-                      <a:r>
-                        <a:t>Exit-ticket P2</a:t>
-                      </a:r>
-                    </a:p>
-                  </a:txBody>
-                  <a:tcPr anchor="ctr">
-                    <a:solidFill>
-                      <a:srgbClr val="F5F7FA"/>
-                    </a:solidFill>
-                  </a:tcPr>
-                </a:tc>
-                <a:tc>
-                  <a:txBody>
-                    <a:bodyPr/>
-                    <a:lstStyle/>
-                    <a:p>
-                      <a:pPr>
-                        <a:defRPr sz="1600" b="1">
-                          <a:solidFill>
-                            <a:srgbClr val="102545"/>
-                          </a:solidFill>
-                        </a:defRPr>
-                      </a:pPr>
-                      <a:r>
-                        <a:t>0 posting. Forum terbuka dan tetap dinilai</a:t>
-                      </a:r>
-                    </a:p>
-                  </a:txBody>
-                  <a:tcPr anchor="ctr">
-                    <a:solidFill>
-                      <a:srgbClr val="F5F7FA"/>
-                    </a:solidFill>
-                  </a:tcPr>
-                </a:tc>
-              </a:tr>
-              <a:tr h="393192">
-                <a:tc>
-                  <a:txBody>
-                    <a:bodyPr/>
-                    <a:lstStyle/>
-                    <a:p>
-                      <a:pPr>
-                        <a:defRPr sz="1600" b="1">
-                          <a:solidFill>
-                            <a:srgbClr val="102545"/>
-                          </a:solidFill>
-                        </a:defRPr>
-                      </a:pPr>
-                      <a:r>
-                        <a:t>Perkenalan</a:t>
-                      </a:r>
-                    </a:p>
-                  </a:txBody>
-                  <a:tcPr anchor="ctr">
-                    <a:solidFill>
-                      <a:srgbClr val="FFFFFF"/>
-                    </a:solidFill>
-                  </a:tcPr>
-                </a:tc>
-                <a:tc>
-                  <a:txBody>
-                    <a:bodyPr/>
-                    <a:lstStyle/>
-                    <a:p>
-                      <a:pPr>
-                        <a:defRPr sz="1600" b="1">
-                          <a:solidFill>
-                            <a:srgbClr val="102545"/>
-                          </a:solidFill>
-                        </a:defRPr>
-                      </a:pPr>
-                      <a:r>
-                        <a:t>5 sudah dibalas dan dinilai 80 (Tyo, Devan, Andrean, Jibril, Marchel)</a:t>
-                      </a:r>
-                    </a:p>
-                  </a:txBody>
-                  <a:tcPr anchor="ctr">
-                    <a:solidFill>
-                      <a:srgbClr val="FFFFFF"/>
-                    </a:solidFill>
-                  </a:tcPr>
-                </a:tc>
-              </a:tr>
-              <a:tr h="393192">
-                <a:tc>
-                  <a:txBody>
-                    <a:bodyPr/>
-                    <a:lstStyle/>
-                    <a:p>
-                      <a:pPr>
-                        <a:defRPr sz="1600" b="1">
-                          <a:solidFill>
-                            <a:srgbClr val="102545"/>
-                          </a:solidFill>
-                        </a:defRPr>
-                      </a:pPr>
-                      <a:r>
-                        <a:t>Kelompok</a:t>
-                      </a:r>
-                    </a:p>
-                  </a:txBody>
-                  <a:tcPr anchor="ctr">
-                    <a:solidFill>
-                      <a:srgbClr val="F5F7FA"/>
-                    </a:solidFill>
-                  </a:tcPr>
-                </a:tc>
-                <a:tc>
-                  <a:txBody>
-                    <a:bodyPr/>
-                    <a:lstStyle/>
-                    <a:p>
-                      <a:pPr>
-                        <a:defRPr sz="1600" b="1">
-                          <a:solidFill>
-                            <a:srgbClr val="102545"/>
-                          </a:solidFill>
-                        </a:defRPr>
-                      </a:pPr>
-                      <a:r>
-                        <a:t>6 kelompok terdaftar di sheet Drive. 4 nama belum tercatat: Firmanda, Yudha, Felix, Setya</a:t>
-                      </a:r>
-                    </a:p>
-                  </a:txBody>
-                  <a:tcPr anchor="ctr">
-                    <a:solidFill>
-                      <a:srgbClr val="F5F7FA"/>
-                    </a:solidFill>
-                  </a:tcPr>
-                </a:tc>
-              </a:tr>
-            </a:tbl>
-          </a:graphicData>
-        </a:graphic>
-      </p:graphicFrame>
-    </p:spTree>
-  </p:cSld>
-  <p:clrMapOvr>
-    <a:masterClrMapping/>
-  </p:clrMapOvr>
-</p:sld>
-</file>
-
-<file path=ppt/slides/slide20.xml><?xml version="1.0" encoding="utf-8"?>
-<p:sld xmlns:a="http://schemas.openxmlformats.org/drawingml/2006/main" xmlns:p="http://schemas.openxmlformats.org/presentationml/2006/main" xmlns:r="http://schemas.openxmlformats.org/officeDocument/2006/relationships">
-  <p:cSld>
-    <p:spTree>
-      <p:nvGrpSpPr>
-        <p:cNvPr id="1" name=""/>
-        <p:cNvGrpSpPr/>
-        <p:nvPr/>
-      </p:nvGrpSpPr>
-      <p:grpSpPr/>
-      <p:sp>
-        <p:nvSpPr>
-          <p:cNvPr id="2" name="Rectangle 1"/>
-          <p:cNvSpPr/>
-          <p:nvPr/>
-        </p:nvSpPr>
-        <p:spPr>
-          <a:xfrm>
-            <a:off x="0" y="0"/>
-            <a:ext cx="12191695" cy="6858000"/>
-          </a:xfrm>
-          <a:prstGeom prst="rect">
-            <a:avLst/>
-          </a:prstGeom>
-          <a:solidFill>
-            <a:srgbClr val="F5F7FA"/>
-          </a:solidFill>
-          <a:ln>
-            <a:noFill/>
-          </a:ln>
-          <a:effectLst/>
-        </p:spPr>
-        <p:style>
-          <a:lnRef idx="1">
-            <a:schemeClr val="accent1"/>
-          </a:lnRef>
-          <a:fillRef idx="3">
-            <a:schemeClr val="accent1"/>
-          </a:fillRef>
-          <a:effectRef idx="2">
-            <a:schemeClr val="accent1"/>
-          </a:effectRef>
-          <a:fontRef idx="minor">
-            <a:schemeClr val="lt1"/>
-          </a:fontRef>
-        </p:style>
-        <p:txBody>
-          <a:bodyPr rtlCol="0" anchor="ctr"/>
-          <a:lstStyle/>
-          <a:p>
-            <a:pPr algn="ctr"/>
-          </a:p>
-        </p:txBody>
-      </p:sp>
-      <p:sp>
-        <p:nvSpPr>
-          <p:cNvPr id="3" name="Rectangle 2"/>
-          <p:cNvSpPr/>
-          <p:nvPr/>
-        </p:nvSpPr>
-        <p:spPr>
-          <a:xfrm>
-            <a:off x="777240" y="2240280"/>
-            <a:ext cx="128016" cy="2011680"/>
-          </a:xfrm>
-          <a:prstGeom prst="rect">
-            <a:avLst/>
-          </a:prstGeom>
-          <a:solidFill>
-            <a:srgbClr val="E6A023"/>
-          </a:solidFill>
-          <a:ln>
-            <a:noFill/>
-          </a:ln>
-          <a:effectLst/>
-        </p:spPr>
-        <p:style>
-          <a:lnRef idx="1">
-            <a:schemeClr val="accent1"/>
-          </a:lnRef>
-          <a:fillRef idx="3">
-            <a:schemeClr val="accent1"/>
-          </a:fillRef>
-          <a:effectRef idx="2">
-            <a:schemeClr val="accent1"/>
-          </a:effectRef>
-          <a:fontRef idx="minor">
-            <a:schemeClr val="lt1"/>
-          </a:fontRef>
-        </p:style>
-        <p:txBody>
-          <a:bodyPr rtlCol="0" anchor="ctr"/>
-          <a:lstStyle/>
-          <a:p>
-            <a:pPr algn="ctr"/>
-          </a:p>
-        </p:txBody>
-      </p:sp>
-      <p:sp>
-        <p:nvSpPr>
-          <p:cNvPr id="4" name="TextBox 3"/>
-          <p:cNvSpPr txBox="1"/>
-          <p:nvPr/>
-        </p:nvSpPr>
-        <p:spPr>
-          <a:xfrm>
-            <a:off x="1234440" y="2148840"/>
-            <a:ext cx="9966960" cy="2103120"/>
-          </a:xfrm>
-          <a:prstGeom prst="rect">
-            <a:avLst/>
-          </a:prstGeom>
-          <a:noFill/>
-        </p:spPr>
-        <p:txBody>
-          <a:bodyPr wrap="square">
-            <a:spAutoFit/>
-          </a:bodyPr>
-          <a:lstStyle/>
-          <a:p>
-            <a:pPr>
-              <a:defRPr sz="3800" b="1">
-                <a:solidFill>
-                  <a:srgbClr val="102545"/>
-                </a:solidFill>
-              </a:defRPr>
-            </a:pPr>
-            <a:r>
-              <a:t>"Kita tidak membangun X"</a:t>
-            </a:r>
-            <a:br/>
-            <a:r>
-              <a:t>adalah kalimat paling mahal di proposal.</a:t>
-            </a:r>
-          </a:p>
-        </p:txBody>
-      </p:sp>
-      <p:sp>
-        <p:nvSpPr>
-          <p:cNvPr id="5" name="TextBox 4"/>
-          <p:cNvSpPr txBox="1"/>
-          <p:nvPr/>
-        </p:nvSpPr>
-        <p:spPr>
-          <a:xfrm>
-            <a:off x="1234440" y="4434840"/>
-            <a:ext cx="9966960" cy="1371600"/>
-          </a:xfrm>
-          <a:prstGeom prst="rect">
-            <a:avLst/>
-          </a:prstGeom>
-          <a:noFill/>
-        </p:spPr>
-        <p:txBody>
-          <a:bodyPr wrap="square">
-            <a:spAutoFit/>
-          </a:bodyPr>
-          <a:lstStyle/>
-          <a:p>
-            <a:pPr>
-              <a:defRPr sz="2100">
-                <a:solidFill>
-                  <a:srgbClr val="5A6372"/>
-                </a:solidFill>
-              </a:defRPr>
-            </a:pPr>
-            <a:r>
-              <a:t>Out-of-Scope menjaga 5 minggu ke depan tidak bocor jadi segala-galanya. Metrik keberhasilan membuat minggu depan ada angka untuk dibandingkan, bukan sekadar perasaan.</a:t>
-            </a:r>
-          </a:p>
-        </p:txBody>
-      </p:sp>
-    </p:spTree>
-  </p:cSld>
-  <p:clrMapOvr>
-    <a:masterClrMapping/>
-  </p:clrMapOvr>
-</p:sld>
-</file>
-
-<file path=ppt/slides/slide21.xml><?xml version="1.0" encoding="utf-8"?>
-<p:sld xmlns:a="http://schemas.openxmlformats.org/drawingml/2006/main" xmlns:p="http://schemas.openxmlformats.org/presentationml/2006/main" xmlns:r="http://schemas.openxmlformats.org/officeDocument/2006/relationships">
-  <p:cSld>
-    <p:spTree>
-      <p:nvGrpSpPr>
-        <p:cNvPr id="1" name=""/>
-        <p:cNvGrpSpPr/>
-        <p:nvPr/>
-      </p:nvGrpSpPr>
-      <p:grpSpPr/>
-      <p:sp>
-        <p:nvSpPr>
-          <p:cNvPr id="2" name="Rectangle 1"/>
-          <p:cNvSpPr/>
-          <p:nvPr/>
-        </p:nvSpPr>
-        <p:spPr>
-          <a:xfrm>
-            <a:off x="0" y="0"/>
-            <a:ext cx="12191695" cy="6858000"/>
-          </a:xfrm>
-          <a:prstGeom prst="rect">
-            <a:avLst/>
-          </a:prstGeom>
-          <a:solidFill>
-            <a:srgbClr val="FFFFFF"/>
-          </a:solidFill>
-          <a:ln>
-            <a:noFill/>
-          </a:ln>
-          <a:effectLst/>
-        </p:spPr>
-        <p:style>
-          <a:lnRef idx="1">
-            <a:schemeClr val="accent1"/>
-          </a:lnRef>
-          <a:fillRef idx="3">
-            <a:schemeClr val="accent1"/>
-          </a:fillRef>
-          <a:effectRef idx="2">
-            <a:schemeClr val="accent1"/>
-          </a:effectRef>
-          <a:fontRef idx="minor">
-            <a:schemeClr val="lt1"/>
-          </a:fontRef>
-        </p:style>
-        <p:txBody>
-          <a:bodyPr rtlCol="0" anchor="ctr"/>
-          <a:lstStyle/>
-          <a:p>
-            <a:pPr algn="ctr"/>
-          </a:p>
-        </p:txBody>
-      </p:sp>
-      <p:sp>
-        <p:nvSpPr>
-          <p:cNvPr id="3" name="Rectangle 2"/>
-          <p:cNvSpPr/>
-          <p:nvPr/>
-        </p:nvSpPr>
-        <p:spPr>
-          <a:xfrm>
-            <a:off x="0" y="0"/>
-            <a:ext cx="12191695" cy="128016"/>
-          </a:xfrm>
-          <a:prstGeom prst="rect">
-            <a:avLst/>
-          </a:prstGeom>
-          <a:solidFill>
-            <a:srgbClr val="102545"/>
-          </a:solidFill>
-          <a:ln>
-            <a:noFill/>
-          </a:ln>
-          <a:effectLst/>
-        </p:spPr>
-        <p:style>
-          <a:lnRef idx="1">
-            <a:schemeClr val="accent1"/>
-          </a:lnRef>
-          <a:fillRef idx="3">
-            <a:schemeClr val="accent1"/>
-          </a:fillRef>
-          <a:effectRef idx="2">
-            <a:schemeClr val="accent1"/>
-          </a:effectRef>
-          <a:fontRef idx="minor">
-            <a:schemeClr val="lt1"/>
-          </a:fontRef>
-        </p:style>
-        <p:txBody>
-          <a:bodyPr rtlCol="0" anchor="ctr"/>
-          <a:lstStyle/>
-          <a:p>
-            <a:pPr algn="ctr"/>
-          </a:p>
-        </p:txBody>
-      </p:sp>
-      <p:sp>
-        <p:nvSpPr>
-          <p:cNvPr id="4" name="TextBox 3"/>
-          <p:cNvSpPr txBox="1"/>
-          <p:nvPr/>
-        </p:nvSpPr>
-        <p:spPr>
-          <a:xfrm>
-            <a:off x="777240" y="411480"/>
-            <a:ext cx="10789920" cy="914400"/>
-          </a:xfrm>
-          <a:prstGeom prst="rect">
-            <a:avLst/>
-          </a:prstGeom>
-          <a:noFill/>
-        </p:spPr>
-        <p:txBody>
-          <a:bodyPr wrap="square">
-            <a:spAutoFit/>
-          </a:bodyPr>
-          <a:lstStyle/>
-          <a:p>
-            <a:pPr>
-              <a:defRPr sz="3400" b="1">
-                <a:solidFill>
-                  <a:srgbClr val="102545"/>
-                </a:solidFill>
-              </a:defRPr>
-            </a:pPr>
-            <a:r>
-              <a:t>Rubrik penilaian Tugas 3 (100 poin)</a:t>
-            </a:r>
-          </a:p>
-        </p:txBody>
-      </p:sp>
-      <p:sp>
-        <p:nvSpPr>
-          <p:cNvPr id="5" name="TextBox 4"/>
-          <p:cNvSpPr txBox="1"/>
-          <p:nvPr/>
-        </p:nvSpPr>
-        <p:spPr>
-          <a:xfrm>
-            <a:off x="777240" y="1188720"/>
-            <a:ext cx="10789920" cy="457200"/>
-          </a:xfrm>
-          <a:prstGeom prst="rect">
-            <a:avLst/>
-          </a:prstGeom>
-          <a:noFill/>
-        </p:spPr>
-        <p:txBody>
-          <a:bodyPr wrap="square">
-            <a:spAutoFit/>
-          </a:bodyPr>
-          <a:lstStyle/>
-          <a:p>
-            <a:pPr>
-              <a:defRPr sz="1800" i="1">
-                <a:solidFill>
-                  <a:srgbClr val="5A6372"/>
-                </a:solidFill>
-              </a:defRPr>
-            </a:pPr>
-            <a:r>
-              <a:t>Kerapian &amp; kepatuhan format termasuk NIM_Nama di berkas individu dan nama kelompok di berkas kelompok.</a:t>
+              <a:t>Kerapian &amp; kepatuhan format: nama kelompok dan seluruh anggota tercantum di berkas.</a:t>
             </a:r>
           </a:p>
         </p:txBody>
@@ -9583,7 +9977,7 @@
 </p:sld>
 </file>
 
-<file path=ppt/slides/slide22.xml><?xml version="1.0" encoding="utf-8"?>
+<file path=ppt/slides/slide23.xml><?xml version="1.0" encoding="utf-8"?>
 <p:sld xmlns:a="http://schemas.openxmlformats.org/drawingml/2006/main" xmlns:p="http://schemas.openxmlformats.org/presentationml/2006/main" xmlns:r="http://schemas.openxmlformats.org/officeDocument/2006/relationships">
   <p:cSld>
     <p:spTree>
@@ -9794,7 +10188,7 @@
 </p:sld>
 </file>
 
-<file path=ppt/slides/slide23.xml><?xml version="1.0" encoding="utf-8"?>
+<file path=ppt/slides/slide24.xml><?xml version="1.0" encoding="utf-8"?>
 <p:sld xmlns:a="http://schemas.openxmlformats.org/drawingml/2006/main" xmlns:p="http://schemas.openxmlformats.org/presentationml/2006/main" xmlns:r="http://schemas.openxmlformats.org/officeDocument/2006/relationships">
   <p:cSld>
     <p:spTree>
@@ -9957,7 +10351,7 @@
               </a:defRPr>
             </a:pPr>
             <a:r>
-              <a:t>Tugas 3a boleh kelompok kecil (max 2 orang); 3b WAJIB individu; 3c satu berkas per kelompok.</a:t>
+              <a:t>Semua bagian = kelompok; yang mengumpulkan sendirian juga sah. Satu set berkas per kelompok.</a:t>
             </a:r>
           </a:p>
         </p:txBody>
@@ -10117,7 +10511,7 @@
                         </a:defRPr>
                       </a:pPr>
                       <a:r>
-                        <a:t>Individu / kelompok kecil</a:t>
+                        <a:t>Kelompok (sendirian sah)</a:t>
                       </a:r>
                     </a:p>
                   </a:txBody>
@@ -10211,7 +10605,7 @@
                         </a:defRPr>
                       </a:pPr>
                       <a:r>
-                        <a:t>Individu</a:t>
+                        <a:t>Kelompok (sendirian sah)</a:t>
                       </a:r>
                     </a:p>
                   </a:txBody>
@@ -10374,7 +10768,7 @@
 </p:sld>
 </file>
 
-<file path=ppt/slides/slide24.xml><?xml version="1.0" encoding="utf-8"?>
+<file path=ppt/slides/slide25.xml><?xml version="1.0" encoding="utf-8"?>
 <p:sld xmlns:a="http://schemas.openxmlformats.org/drawingml/2006/main" xmlns:p="http://schemas.openxmlformats.org/presentationml/2006/main" xmlns:r="http://schemas.openxmlformats.org/officeDocument/2006/relationships">
   <p:cSld>
     <p:spTree>
@@ -10666,7 +11060,7 @@
 </p:sld>
 </file>
 
-<file path=ppt/slides/slide25.xml><?xml version="1.0" encoding="utf-8"?>
+<file path=ppt/slides/slide26.xml><?xml version="1.0" encoding="utf-8"?>
 <p:sld xmlns:a="http://schemas.openxmlformats.org/drawingml/2006/main" xmlns:p="http://schemas.openxmlformats.org/presentationml/2006/main" xmlns:r="http://schemas.openxmlformats.org/officeDocument/2006/relationships">
   <p:cSld>
     <p:spTree>
@@ -10970,7 +11364,7 @@
 </p:sld>
 </file>
 
-<file path=ppt/slides/slide26.xml><?xml version="1.0" encoding="utf-8"?>
+<file path=ppt/slides/slide27.xml><?xml version="1.0" encoding="utf-8"?>
 <p:sld xmlns:a="http://schemas.openxmlformats.org/drawingml/2006/main" xmlns:p="http://schemas.openxmlformats.org/presentationml/2006/main" xmlns:r="http://schemas.openxmlformats.org/officeDocument/2006/relationships">
   <p:cSld>
     <p:spTree>
@@ -13229,7 +13623,7 @@
               </a:defRPr>
             </a:pPr>
             <a:r>
-              <a:t>Belum tercatat: Firmanda, Yudha, Felix, Setya - lengkapi sheet hari ini sebelum kelas bubar; tanpa kelompok, Tugas 3c tidak bisa dinilai.</a:t>
+              <a:t>Belum tercatat: Firmanda, Yudha, Felix, Setya - kelompok boleh terbentuk belakangan; yang belum punya kelompok tetap boleh mengerjakan sendirian.</a:t>
             </a:r>
           </a:p>
         </p:txBody>
@@ -13629,6 +14023,186 @@
             <a:avLst/>
           </a:prstGeom>
           <a:solidFill>
+            <a:srgbClr val="F5F7FA"/>
+          </a:solidFill>
+          <a:ln>
+            <a:noFill/>
+          </a:ln>
+          <a:effectLst/>
+        </p:spPr>
+        <p:style>
+          <a:lnRef idx="1">
+            <a:schemeClr val="accent1"/>
+          </a:lnRef>
+          <a:fillRef idx="3">
+            <a:schemeClr val="accent1"/>
+          </a:fillRef>
+          <a:effectRef idx="2">
+            <a:schemeClr val="accent1"/>
+          </a:effectRef>
+          <a:fontRef idx="minor">
+            <a:schemeClr val="lt1"/>
+          </a:fontRef>
+        </p:style>
+        <p:txBody>
+          <a:bodyPr rtlCol="0" anchor="ctr"/>
+          <a:lstStyle/>
+          <a:p>
+            <a:pPr algn="ctr"/>
+          </a:p>
+        </p:txBody>
+      </p:sp>
+      <p:sp>
+        <p:nvSpPr>
+          <p:cNvPr id="3" name="Rectangle 2"/>
+          <p:cNvSpPr/>
+          <p:nvPr/>
+        </p:nvSpPr>
+        <p:spPr>
+          <a:xfrm>
+            <a:off x="777240" y="2240280"/>
+            <a:ext cx="128016" cy="2011680"/>
+          </a:xfrm>
+          <a:prstGeom prst="rect">
+            <a:avLst/>
+          </a:prstGeom>
+          <a:solidFill>
+            <a:srgbClr val="E6A023"/>
+          </a:solidFill>
+          <a:ln>
+            <a:noFill/>
+          </a:ln>
+          <a:effectLst/>
+        </p:spPr>
+        <p:style>
+          <a:lnRef idx="1">
+            <a:schemeClr val="accent1"/>
+          </a:lnRef>
+          <a:fillRef idx="3">
+            <a:schemeClr val="accent1"/>
+          </a:fillRef>
+          <a:effectRef idx="2">
+            <a:schemeClr val="accent1"/>
+          </a:effectRef>
+          <a:fontRef idx="minor">
+            <a:schemeClr val="lt1"/>
+          </a:fontRef>
+        </p:style>
+        <p:txBody>
+          <a:bodyPr rtlCol="0" anchor="ctr"/>
+          <a:lstStyle/>
+          <a:p>
+            <a:pPr algn="ctr"/>
+          </a:p>
+        </p:txBody>
+      </p:sp>
+      <p:sp>
+        <p:nvSpPr>
+          <p:cNvPr id="4" name="TextBox 3"/>
+          <p:cNvSpPr txBox="1"/>
+          <p:nvPr/>
+        </p:nvSpPr>
+        <p:spPr>
+          <a:xfrm>
+            <a:off x="1234440" y="2148840"/>
+            <a:ext cx="9966960" cy="2103120"/>
+          </a:xfrm>
+          <a:prstGeom prst="rect">
+            <a:avLst/>
+          </a:prstGeom>
+          <a:noFill/>
+        </p:spPr>
+        <p:txBody>
+          <a:bodyPr wrap="square">
+            <a:spAutoFit/>
+          </a:bodyPr>
+          <a:lstStyle/>
+          <a:p>
+            <a:pPr>
+              <a:defRPr sz="3800" b="1">
+                <a:solidFill>
+                  <a:srgbClr val="102545"/>
+                </a:solidFill>
+              </a:defRPr>
+            </a:pPr>
+            <a:r>
+              <a:t>Kebijakan AP:</a:t>
+            </a:r>
+            <a:br/>
+            <a:r>
+              <a:t>semua tugas adalah tugas kelompok.</a:t>
+            </a:r>
+          </a:p>
+        </p:txBody>
+      </p:sp>
+      <p:sp>
+        <p:nvSpPr>
+          <p:cNvPr id="5" name="TextBox 4"/>
+          <p:cNvSpPr txBox="1"/>
+          <p:nvPr/>
+        </p:nvSpPr>
+        <p:spPr>
+          <a:xfrm>
+            <a:off x="1234440" y="4434840"/>
+            <a:ext cx="9966960" cy="1371600"/>
+          </a:xfrm>
+          <a:prstGeom prst="rect">
+            <a:avLst/>
+          </a:prstGeom>
+          <a:noFill/>
+        </p:spPr>
+        <p:txBody>
+          <a:bodyPr wrap="square">
+            <a:spAutoFit/>
+          </a:bodyPr>
+          <a:lstStyle/>
+          <a:p>
+            <a:pPr>
+              <a:defRPr sz="2100">
+                <a:solidFill>
+                  <a:srgbClr val="5A6372"/>
+                </a:solidFill>
+              </a:defRPr>
+            </a:pPr>
+            <a:r>
+              <a:t>Seluruh tugas semester ini adalah potongan satu proyek kelompok yang berakhir di PAMERAN proyek. Yang mengerjakan sendirian juga sah - kelompok boleh terbentuk belakangan. Yang penting: nama kelompok dan seluruh anggota tercatat di berkas dan di sheet.</a:t>
+            </a:r>
+          </a:p>
+        </p:txBody>
+      </p:sp>
+    </p:spTree>
+  </p:cSld>
+  <p:clrMapOvr>
+    <a:masterClrMapping/>
+  </p:clrMapOvr>
+</p:sld>
+</file>
+
+<file path=ppt/slides/slide7.xml><?xml version="1.0" encoding="utf-8"?>
+<p:sld xmlns:a="http://schemas.openxmlformats.org/drawingml/2006/main" xmlns:p="http://schemas.openxmlformats.org/presentationml/2006/main" xmlns:r="http://schemas.openxmlformats.org/officeDocument/2006/relationships">
+  <p:cSld>
+    <p:spTree>
+      <p:nvGrpSpPr>
+        <p:cNvPr id="1" name=""/>
+        <p:cNvGrpSpPr/>
+        <p:nvPr/>
+      </p:nvGrpSpPr>
+      <p:grpSpPr/>
+      <p:sp>
+        <p:nvSpPr>
+          <p:cNvPr id="2" name="Rectangle 1"/>
+          <p:cNvSpPr/>
+          <p:nvPr/>
+        </p:nvSpPr>
+        <p:spPr>
+          <a:xfrm>
+            <a:off x="0" y="0"/>
+            <a:ext cx="12191695" cy="6858000"/>
+          </a:xfrm>
+          <a:prstGeom prst="rect">
+            <a:avLst/>
+          </a:prstGeom>
+          <a:solidFill>
             <a:srgbClr val="FFFFFF"/>
           </a:solidFill>
           <a:ln>
@@ -13958,7 +14532,7 @@
 </p:sld>
 </file>
 
-<file path=ppt/slides/slide7.xml><?xml version="1.0" encoding="utf-8"?>
+<file path=ppt/slides/slide8.xml><?xml version="1.0" encoding="utf-8"?>
 <p:sld xmlns:a="http://schemas.openxmlformats.org/drawingml/2006/main" xmlns:p="http://schemas.openxmlformats.org/presentationml/2006/main" xmlns:r="http://schemas.openxmlformats.org/officeDocument/2006/relationships">
   <p:cSld>
     <p:spTree>
@@ -14173,7 +14747,7 @@
 </p:sld>
 </file>
 
-<file path=ppt/slides/slide8.xml><?xml version="1.0" encoding="utf-8"?>
+<file path=ppt/slides/slide9.xml><?xml version="1.0" encoding="utf-8"?>
 <p:sld xmlns:a="http://schemas.openxmlformats.org/drawingml/2006/main" xmlns:p="http://schemas.openxmlformats.org/presentationml/2006/main" xmlns:r="http://schemas.openxmlformats.org/officeDocument/2006/relationships">
   <p:cSld>
     <p:spTree>
@@ -14341,329 +14915,6 @@
             </a:pPr>
             <a:r>
               <a:t>Pertemuan 1-2 Anda membangun struktur. Hari ini kita beri dia kulit yang konsisten: keputusan warna, huruf, dan jarak yang bisa dipertanggungjawabkan - bukan tempelan rasa.</a:t>
-            </a:r>
-          </a:p>
-        </p:txBody>
-      </p:sp>
-    </p:spTree>
-  </p:cSld>
-  <p:clrMapOvr>
-    <a:masterClrMapping/>
-  </p:clrMapOvr>
-</p:sld>
-</file>
-
-<file path=ppt/slides/slide9.xml><?xml version="1.0" encoding="utf-8"?>
-<p:sld xmlns:a="http://schemas.openxmlformats.org/drawingml/2006/main" xmlns:p="http://schemas.openxmlformats.org/presentationml/2006/main" xmlns:r="http://schemas.openxmlformats.org/officeDocument/2006/relationships">
-  <p:cSld>
-    <p:spTree>
-      <p:nvGrpSpPr>
-        <p:cNvPr id="1" name=""/>
-        <p:cNvGrpSpPr/>
-        <p:nvPr/>
-      </p:nvGrpSpPr>
-      <p:grpSpPr/>
-      <p:sp>
-        <p:nvSpPr>
-          <p:cNvPr id="2" name="Rectangle 1"/>
-          <p:cNvSpPr/>
-          <p:nvPr/>
-        </p:nvSpPr>
-        <p:spPr>
-          <a:xfrm>
-            <a:off x="0" y="0"/>
-            <a:ext cx="12191695" cy="6858000"/>
-          </a:xfrm>
-          <a:prstGeom prst="rect">
-            <a:avLst/>
-          </a:prstGeom>
-          <a:solidFill>
-            <a:srgbClr val="FFFFFF"/>
-          </a:solidFill>
-          <a:ln>
-            <a:noFill/>
-          </a:ln>
-          <a:effectLst/>
-        </p:spPr>
-        <p:style>
-          <a:lnRef idx="1">
-            <a:schemeClr val="accent1"/>
-          </a:lnRef>
-          <a:fillRef idx="3">
-            <a:schemeClr val="accent1"/>
-          </a:fillRef>
-          <a:effectRef idx="2">
-            <a:schemeClr val="accent1"/>
-          </a:effectRef>
-          <a:fontRef idx="minor">
-            <a:schemeClr val="lt1"/>
-          </a:fontRef>
-        </p:style>
-        <p:txBody>
-          <a:bodyPr rtlCol="0" anchor="ctr"/>
-          <a:lstStyle/>
-          <a:p>
-            <a:pPr algn="ctr"/>
-          </a:p>
-        </p:txBody>
-      </p:sp>
-      <p:sp>
-        <p:nvSpPr>
-          <p:cNvPr id="3" name="Rectangle 2"/>
-          <p:cNvSpPr/>
-          <p:nvPr/>
-        </p:nvSpPr>
-        <p:spPr>
-          <a:xfrm>
-            <a:off x="0" y="0"/>
-            <a:ext cx="12191695" cy="128016"/>
-          </a:xfrm>
-          <a:prstGeom prst="rect">
-            <a:avLst/>
-          </a:prstGeom>
-          <a:solidFill>
-            <a:srgbClr val="102545"/>
-          </a:solidFill>
-          <a:ln>
-            <a:noFill/>
-          </a:ln>
-          <a:effectLst/>
-        </p:spPr>
-        <p:style>
-          <a:lnRef idx="1">
-            <a:schemeClr val="accent1"/>
-          </a:lnRef>
-          <a:fillRef idx="3">
-            <a:schemeClr val="accent1"/>
-          </a:fillRef>
-          <a:effectRef idx="2">
-            <a:schemeClr val="accent1"/>
-          </a:effectRef>
-          <a:fontRef idx="minor">
-            <a:schemeClr val="lt1"/>
-          </a:fontRef>
-        </p:style>
-        <p:txBody>
-          <a:bodyPr rtlCol="0" anchor="ctr"/>
-          <a:lstStyle/>
-          <a:p>
-            <a:pPr algn="ctr"/>
-          </a:p>
-        </p:txBody>
-      </p:sp>
-      <p:sp>
-        <p:nvSpPr>
-          <p:cNvPr id="4" name="TextBox 3"/>
-          <p:cNvSpPr txBox="1"/>
-          <p:nvPr/>
-        </p:nvSpPr>
-        <p:spPr>
-          <a:xfrm>
-            <a:off x="777240" y="411480"/>
-            <a:ext cx="10789920" cy="914400"/>
-          </a:xfrm>
-          <a:prstGeom prst="rect">
-            <a:avLst/>
-          </a:prstGeom>
-          <a:noFill/>
-        </p:spPr>
-        <p:txBody>
-          <a:bodyPr wrap="square">
-            <a:spAutoFit/>
-          </a:bodyPr>
-          <a:lstStyle/>
-          <a:p>
-            <a:pPr>
-              <a:defRPr sz="3400" b="1">
-                <a:solidFill>
-                  <a:srgbClr val="102545"/>
-                </a:solidFill>
-              </a:defRPr>
-            </a:pPr>
-            <a:r>
-              <a:t>Peta kerja hari ini</a:t>
-            </a:r>
-          </a:p>
-        </p:txBody>
-      </p:sp>
-      <p:sp>
-        <p:nvSpPr>
-          <p:cNvPr id="5" name="TextBox 4"/>
-          <p:cNvSpPr txBox="1"/>
-          <p:nvPr/>
-        </p:nvSpPr>
-        <p:spPr>
-          <a:xfrm>
-            <a:off x="777240" y="1234440"/>
-            <a:ext cx="10789920" cy="548640"/>
-          </a:xfrm>
-          <a:prstGeom prst="rect">
-            <a:avLst/>
-          </a:prstGeom>
-          <a:noFill/>
-        </p:spPr>
-        <p:txBody>
-          <a:bodyPr wrap="square">
-            <a:spAutoFit/>
-          </a:bodyPr>
-          <a:lstStyle/>
-          <a:p>
-            <a:pPr>
-              <a:defRPr sz="1900" i="1">
-                <a:solidFill>
-                  <a:srgbClr val="5A6372"/>
-                </a:solidFill>
-              </a:defRPr>
-            </a:pPr>
-            <a:r>
-              <a:t>Urutannya tidak boleh dibalik: mockup tanpa style guide = setiap layar punya selera sendiri.</a:t>
-            </a:r>
-          </a:p>
-        </p:txBody>
-      </p:sp>
-      <p:sp>
-        <p:nvSpPr>
-          <p:cNvPr id="6" name="TextBox 5"/>
-          <p:cNvSpPr txBox="1"/>
-          <p:nvPr/>
-        </p:nvSpPr>
-        <p:spPr>
-          <a:xfrm>
-            <a:off x="777240" y="1874519"/>
-            <a:ext cx="10789920" cy="4480560"/>
-          </a:xfrm>
-          <a:prstGeom prst="rect">
-            <a:avLst/>
-          </a:prstGeom>
-          <a:noFill/>
-        </p:spPr>
-        <p:txBody>
-          <a:bodyPr wrap="square">
-            <a:spAutoFit/>
-          </a:bodyPr>
-          <a:lstStyle/>
-          <a:p>
-            <a:pPr>
-              <a:spcBef>
-                <a:spcPts val="1100"/>
-              </a:spcBef>
-            </a:pPr>
-            <a:r>
-              <a:rPr sz="2200">
-                <a:solidFill>
-                  <a:srgbClr val="1A1F2B"/>
-                </a:solidFill>
-              </a:rPr>
-              <a:t>•  </a:t>
-            </a:r>
-            <a:r>
-              <a:rPr sz="2200" b="1">
-                <a:solidFill>
-                  <a:srgbClr val="102545"/>
-                </a:solidFill>
-              </a:rPr>
-              <a:t>Audit visual</a:t>
-            </a:r>
-            <a:r>
-              <a:rPr sz="2200">
-                <a:solidFill>
-                  <a:srgbClr val="1A1F2B"/>
-                </a:solidFill>
-              </a:rPr>
-              <a:t> wireframe P2 dengan kacamata estetika - catat minimal 3 temuan</a:t>
-            </a:r>
-          </a:p>
-          <a:p>
-            <a:pPr>
-              <a:spcBef>
-                <a:spcPts val="1100"/>
-              </a:spcBef>
-            </a:pPr>
-            <a:r>
-              <a:rPr sz="2200">
-                <a:solidFill>
-                  <a:srgbClr val="1A1F2B"/>
-                </a:solidFill>
-              </a:rPr>
-              <a:t>•  </a:t>
-            </a:r>
-            <a:r>
-              <a:rPr sz="2200" b="1">
-                <a:solidFill>
-                  <a:srgbClr val="102545"/>
-                </a:solidFill>
-              </a:rPr>
-              <a:t>Style guide 1 halaman</a:t>
-            </a:r>
-            <a:r>
-              <a:rPr sz="2200">
-                <a:solidFill>
-                  <a:srgbClr val="1A1F2B"/>
-                </a:solidFill>
-              </a:rPr>
-              <a:t> - palet, type scale, komponen + state, aturan spacing</a:t>
-            </a:r>
-          </a:p>
-          <a:p>
-            <a:pPr>
-              <a:spcBef>
-                <a:spcPts val="1100"/>
-              </a:spcBef>
-            </a:pPr>
-            <a:r>
-              <a:rPr sz="2200">
-                <a:solidFill>
-                  <a:srgbClr val="1A1F2B"/>
-                </a:solidFill>
-              </a:rPr>
-              <a:t>•  </a:t>
-            </a:r>
-            <a:r>
-              <a:rPr sz="2200" b="1">
-                <a:solidFill>
-                  <a:srgbClr val="102545"/>
-                </a:solidFill>
-              </a:rPr>
-              <a:t>Mockup fidelity menengah, 2 layar</a:t>
-            </a:r>
-            <a:r>
-              <a:rPr sz="2200">
-                <a:solidFill>
-                  <a:srgbClr val="1A1F2B"/>
-                </a:solidFill>
-              </a:rPr>
-              <a:t> - Beranda + Layar Fitur Inti</a:t>
-            </a:r>
-          </a:p>
-          <a:p>
-            <a:pPr>
-              <a:spcBef>
-                <a:spcPts val="1100"/>
-              </a:spcBef>
-            </a:pPr>
-            <a:r>
-              <a:rPr sz="2200">
-                <a:solidFill>
-                  <a:srgbClr val="1A1F2B"/>
-                </a:solidFill>
-              </a:rPr>
-              <a:t>•  </a:t>
-            </a:r>
-            <a:r>
-              <a:rPr sz="2200" b="1">
-                <a:solidFill>
-                  <a:srgbClr val="102545"/>
-                </a:solidFill>
-              </a:rPr>
-              <a:t>Draft proposal 1-2 halaman</a:t>
-            </a:r>
-            <a:r>
-              <a:rPr sz="2200">
-                <a:solidFill>
-                  <a:srgbClr val="1A1F2B"/>
-                </a:solidFill>
-              </a:rPr>
-              <a:t> - 7 komponen, kerja kelompok</a:t>
             </a:r>
           </a:p>
         </p:txBody>

</xml_diff>